<commit_message>
fix(deck): use the wide slide layout, size screenshots to ratio and ship a pdf
</commit_message>
<xml_diff>
--- a/docs/SkillProof_Pitch.pptx
+++ b/docs/SkillProof_Pitch.pptx
@@ -21,8 +21,8 @@
   <p:notesMasterIdLst>
     <p:notesMasterId r:id="rId14"/>
   </p:notesMasterIdLst>
-  <p:sldSz cx="9144000" cy="5143500"/>
-  <p:notesSz cx="5143500" cy="9144000"/>
+  <p:sldSz cx="12192000" cy="6858000"/>
+  <p:notesSz cx="6858000" cy="12192000"/>
   <p:defaultTextStyle>
     <a:lvl1pPr marL="0" algn="l" defTabSz="914400" rtl="0" eaLnBrk="1" latinLnBrk="0" hangingPunct="1">
       <a:defRPr sz="1800" kern="1200">
@@ -1907,9 +1907,9 @@
                 <a:solidFill>
                   <a:srgbClr val="FFFFFF"/>
                 </a:solidFill>
-                <a:latin typeface="Schibsted Grotesk" pitchFamily="34" charset="0"/>
-                <a:ea typeface="Schibsted Grotesk" pitchFamily="34" charset="-122"/>
-                <a:cs typeface="Schibsted Grotesk" pitchFamily="34" charset="-120"/>
+                <a:latin typeface="Arial" pitchFamily="34" charset="0"/>
+                <a:ea typeface="Arial" pitchFamily="34" charset="-122"/>
+                <a:cs typeface="Arial" pitchFamily="34" charset="-120"/>
               </a:rPr>
               <a:t>Skills proven, not claimed.</a:t>
             </a:r>
@@ -1926,7 +1926,7 @@
         <p:spPr>
           <a:xfrm>
             <a:off x="822960" y="3749040"/>
-            <a:ext cx="8778240" cy="822960"/>
+            <a:ext cx="8046720" cy="1005840"/>
           </a:xfrm>
           <a:prstGeom prst="rect">
             <a:avLst/>
@@ -1942,17 +1942,17 @@
               <a:buNone/>
             </a:pPr>
             <a:r>
-              <a:rPr lang="en-US" sz="1700" dirty="0">
+              <a:rPr lang="en-US" sz="1600" dirty="0">
                 <a:solidFill>
                   <a:srgbClr val="AEB7D6"/>
                 </a:solidFill>
-                <a:latin typeface="IBM Plex Sans" pitchFamily="34" charset="0"/>
-                <a:ea typeface="IBM Plex Sans" pitchFamily="34" charset="-122"/>
-                <a:cs typeface="IBM Plex Sans" pitchFamily="34" charset="-120"/>
+                <a:latin typeface="Arial" pitchFamily="34" charset="0"/>
+                <a:ea typeface="Arial" pitchFamily="34" charset="-122"/>
+                <a:cs typeface="Arial" pitchFamily="34" charset="-120"/>
               </a:rPr>
               <a:t>SkillProof turns a student profile into a measurable readiness score and an adaptive roadmap, with the evidence behind every number.</a:t>
             </a:r>
-            <a:endParaRPr lang="en-US" sz="1700" dirty="0"/>
+            <a:endParaRPr lang="en-US" sz="1600" dirty="0"/>
           </a:p>
         </p:txBody>
       </p:sp>
@@ -1985,9 +1985,9 @@
                 <a:solidFill>
                   <a:srgbClr val="8A93B8"/>
                 </a:solidFill>
-                <a:latin typeface="IBM Plex Sans" pitchFamily="34" charset="0"/>
-                <a:ea typeface="IBM Plex Sans" pitchFamily="34" charset="-122"/>
-                <a:cs typeface="IBM Plex Sans" pitchFamily="34" charset="-120"/>
+                <a:latin typeface="Arial" pitchFamily="34" charset="0"/>
+                <a:ea typeface="Arial" pitchFamily="34" charset="-122"/>
+                <a:cs typeface="Arial" pitchFamily="34" charset="-120"/>
               </a:rPr>
               <a:t>Bit N Build 2026, UP Regionals  |  Problem statement 05, education and employability</a:t>
             </a:r>
@@ -2080,9 +2080,9 @@
                 <a:solidFill>
                   <a:srgbClr val="1B2240"/>
                 </a:solidFill>
-                <a:latin typeface="Schibsted Grotesk" pitchFamily="34" charset="0"/>
-                <a:ea typeface="Schibsted Grotesk" pitchFamily="34" charset="-122"/>
-                <a:cs typeface="Schibsted Grotesk" pitchFamily="34" charset="-120"/>
+                <a:latin typeface="Arial" pitchFamily="34" charset="0"/>
+                <a:ea typeface="Arial" pitchFamily="34" charset="-122"/>
+                <a:cs typeface="Arial" pitchFamily="34" charset="-120"/>
               </a:rPr>
               <a:t>SkillProof</a:t>
             </a:r>
@@ -2119,9 +2119,9 @@
                 <a:solidFill>
                   <a:srgbClr val="1B2240"/>
                 </a:solidFill>
-                <a:latin typeface="Schibsted Grotesk" pitchFamily="34" charset="0"/>
-                <a:ea typeface="Schibsted Grotesk" pitchFamily="34" charset="-122"/>
-                <a:cs typeface="Schibsted Grotesk" pitchFamily="34" charset="-120"/>
+                <a:latin typeface="Arial" pitchFamily="34" charset="0"/>
+                <a:ea typeface="Arial" pitchFamily="34" charset="-122"/>
+                <a:cs typeface="Arial" pitchFamily="34" charset="-120"/>
               </a:rPr>
               <a:t>How it is built</a:t>
             </a:r>
@@ -2158,9 +2158,9 @@
                 <a:solidFill>
                   <a:srgbClr val="5E6785"/>
                 </a:solidFill>
-                <a:latin typeface="IBM Plex Sans" pitchFamily="34" charset="0"/>
-                <a:ea typeface="IBM Plex Sans" pitchFamily="34" charset="-122"/>
-                <a:cs typeface="IBM Plex Sans" pitchFamily="34" charset="-120"/>
+                <a:latin typeface="Arial" pitchFamily="34" charset="0"/>
+                <a:ea typeface="Arial" pitchFamily="34" charset="-122"/>
+                <a:cs typeface="Arial" pitchFamily="34" charset="-120"/>
               </a:rPr>
               <a:t>Deterministic where it matters, AI where it helps.</a:t>
             </a:r>
@@ -2217,9 +2217,9 @@
                 <a:solidFill>
                   <a:srgbClr val="1B2240"/>
                 </a:solidFill>
-                <a:latin typeface="Schibsted Grotesk" pitchFamily="34" charset="0"/>
-                <a:ea typeface="Schibsted Grotesk" pitchFamily="34" charset="-122"/>
-                <a:cs typeface="Schibsted Grotesk" pitchFamily="34" charset="-120"/>
+                <a:latin typeface="Arial" pitchFamily="34" charset="0"/>
+                <a:ea typeface="Arial" pitchFamily="34" charset="-122"/>
+                <a:cs typeface="Arial" pitchFamily="34" charset="-120"/>
               </a:rPr>
               <a:t>Deterministic core</a:t>
             </a:r>
@@ -2256,9 +2256,9 @@
                 <a:solidFill>
                   <a:srgbClr val="5E6785"/>
                 </a:solidFill>
-                <a:latin typeface="IBM Plex Sans" pitchFamily="34" charset="0"/>
-                <a:ea typeface="IBM Plex Sans" pitchFamily="34" charset="-122"/>
-                <a:cs typeface="IBM Plex Sans" pitchFamily="34" charset="-120"/>
+                <a:latin typeface="Arial" pitchFamily="34" charset="0"/>
+                <a:ea typeface="Arial" pitchFamily="34" charset="-122"/>
+                <a:cs typeface="Arial" pitchFamily="34" charset="-120"/>
               </a:rPr>
               <a:t>scoring, gap ranking and skill detection are plain TypeScript, so the same profile always gives the same score</a:t>
             </a:r>
@@ -2315,9 +2315,9 @@
                 <a:solidFill>
                   <a:srgbClr val="1B2240"/>
                 </a:solidFill>
-                <a:latin typeface="Schibsted Grotesk" pitchFamily="34" charset="0"/>
-                <a:ea typeface="Schibsted Grotesk" pitchFamily="34" charset="-122"/>
-                <a:cs typeface="Schibsted Grotesk" pitchFamily="34" charset="-120"/>
+                <a:latin typeface="Arial" pitchFamily="34" charset="0"/>
+                <a:ea typeface="Arial" pitchFamily="34" charset="-122"/>
+                <a:cs typeface="Arial" pitchFamily="34" charset="-120"/>
               </a:rPr>
               <a:t>AI at the edges</a:t>
             </a:r>
@@ -2354,9 +2354,9 @@
                 <a:solidFill>
                   <a:srgbClr val="5E6785"/>
                 </a:solidFill>
-                <a:latin typeface="IBM Plex Sans" pitchFamily="34" charset="0"/>
-                <a:ea typeface="IBM Plex Sans" pitchFamily="34" charset="-122"/>
-                <a:cs typeface="IBM Plex Sans" pitchFamily="34" charset="-120"/>
+                <a:latin typeface="Arial" pitchFamily="34" charset="0"/>
+                <a:ea typeface="Arial" pitchFamily="34" charset="-122"/>
+                <a:cs typeface="Arial" pitchFamily="34" charset="-120"/>
               </a:rPr>
               <a:t>Sarvam AI writes the explanations and quiz questions, with Groq and Gemini as fallbacks</a:t>
             </a:r>
@@ -2413,9 +2413,9 @@
                 <a:solidFill>
                   <a:srgbClr val="1B2240"/>
                 </a:solidFill>
-                <a:latin typeface="Schibsted Grotesk" pitchFamily="34" charset="0"/>
-                <a:ea typeface="Schibsted Grotesk" pitchFamily="34" charset="-122"/>
-                <a:cs typeface="Schibsted Grotesk" pitchFamily="34" charset="-120"/>
+                <a:latin typeface="Arial" pitchFamily="34" charset="0"/>
+                <a:ea typeface="Arial" pitchFamily="34" charset="-122"/>
+                <a:cs typeface="Arial" pitchFamily="34" charset="-120"/>
               </a:rPr>
               <a:t>Everything validated</a:t>
             </a:r>
@@ -2452,9 +2452,9 @@
                 <a:solidFill>
                   <a:srgbClr val="5E6785"/>
                 </a:solidFill>
-                <a:latin typeface="IBM Plex Sans" pitchFamily="34" charset="0"/>
-                <a:ea typeface="IBM Plex Sans" pitchFamily="34" charset="-122"/>
-                <a:cs typeface="IBM Plex Sans" pitchFamily="34" charset="-120"/>
+                <a:latin typeface="Arial" pitchFamily="34" charset="0"/>
+                <a:ea typeface="Arial" pitchFamily="34" charset="-122"/>
+                <a:cs typeface="Arial" pitchFamily="34" charset="-120"/>
               </a:rPr>
               <a:t>zod at every boundary, one repair retry, then the next provider, then built in logic</a:t>
             </a:r>
@@ -2511,9 +2511,9 @@
                 <a:solidFill>
                   <a:srgbClr val="1B2240"/>
                 </a:solidFill>
-                <a:latin typeface="Schibsted Grotesk" pitchFamily="34" charset="0"/>
-                <a:ea typeface="Schibsted Grotesk" pitchFamily="34" charset="-122"/>
-                <a:cs typeface="Schibsted Grotesk" pitchFamily="34" charset="-120"/>
+                <a:latin typeface="Arial" pitchFamily="34" charset="0"/>
+                <a:ea typeface="Arial" pitchFamily="34" charset="-122"/>
+                <a:cs typeface="Arial" pitchFamily="34" charset="-120"/>
               </a:rPr>
               <a:t>Runs with zero keys</a:t>
             </a:r>
@@ -2550,9 +2550,9 @@
                 <a:solidFill>
                   <a:srgbClr val="5E6785"/>
                 </a:solidFill>
-                <a:latin typeface="IBM Plex Sans" pitchFamily="34" charset="0"/>
-                <a:ea typeface="IBM Plex Sans" pitchFamily="34" charset="-122"/>
-                <a:cs typeface="IBM Plex Sans" pitchFamily="34" charset="-120"/>
+                <a:latin typeface="Arial" pitchFamily="34" charset="0"/>
+                <a:ea typeface="Arial" pitchFamily="34" charset="-122"/>
+                <a:cs typeface="Arial" pitchFamily="34" charset="-120"/>
               </a:rPr>
               <a:t>the whole product works on deterministic logic when no provider is available</a:t>
             </a:r>
@@ -2645,9 +2645,9 @@
                 <a:solidFill>
                   <a:srgbClr val="1B2240"/>
                 </a:solidFill>
-                <a:latin typeface="Schibsted Grotesk" pitchFamily="34" charset="0"/>
-                <a:ea typeface="Schibsted Grotesk" pitchFamily="34" charset="-122"/>
-                <a:cs typeface="Schibsted Grotesk" pitchFamily="34" charset="-120"/>
+                <a:latin typeface="Arial" pitchFamily="34" charset="0"/>
+                <a:ea typeface="Arial" pitchFamily="34" charset="-122"/>
+                <a:cs typeface="Arial" pitchFamily="34" charset="-120"/>
               </a:rPr>
               <a:t>SkillProof</a:t>
             </a:r>
@@ -2684,9 +2684,9 @@
                 <a:solidFill>
                   <a:srgbClr val="1B2240"/>
                 </a:solidFill>
-                <a:latin typeface="Schibsted Grotesk" pitchFamily="34" charset="0"/>
-                <a:ea typeface="Schibsted Grotesk" pitchFamily="34" charset="-122"/>
-                <a:cs typeface="Schibsted Grotesk" pitchFamily="34" charset="-120"/>
+                <a:latin typeface="Arial" pitchFamily="34" charset="0"/>
+                <a:ea typeface="Arial" pitchFamily="34" charset="-122"/>
+                <a:cs typeface="Arial" pitchFamily="34" charset="-120"/>
               </a:rPr>
               <a:t>Stack and engineering</a:t>
             </a:r>
@@ -2709,7 +2709,7 @@
           </p:nvPr>
         </p:nvGraphicFramePr>
         <p:xfrm>
-          <a:off x="502920" y="2103120"/>
+          <a:off x="502920" y="2194560"/>
           <a:ext cx="11183112" cy="914400"/>
         </p:xfrm>
         <a:graphic>
@@ -2720,7 +2720,7 @@
                 <a:gridCol w="5591556"/>
                 <a:gridCol w="5591556"/>
               </a:tblGrid>
-              <a:tr h="457200">
+              <a:tr h="658368">
                 <a:tc>
                   <a:txBody>
                     <a:bodyPr/>
@@ -2734,16 +2734,16 @@
                           <a:solidFill>
                             <a:srgbClr val="1B2240"/>
                           </a:solidFill>
-                          <a:latin typeface="Schibsted Grotesk" pitchFamily="34" charset="0"/>
-                          <a:ea typeface="Schibsted Grotesk" pitchFamily="34" charset="-122"/>
-                          <a:cs typeface="Schibsted Grotesk" pitchFamily="34" charset="-120"/>
+                          <a:latin typeface="Arial" pitchFamily="34" charset="0"/>
+                          <a:ea typeface="Arial" pitchFamily="34" charset="-122"/>
+                          <a:cs typeface="Arial" pitchFamily="34" charset="-120"/>
                         </a:rPr>
                         <a:t>Layer</a:t>
                       </a:r>
                       <a:endParaRPr lang="en-US" sz="1300" dirty="0">
-                        <a:latin typeface="Schibsted Grotesk" charset="0"/>
-                        <a:ea typeface="Schibsted Grotesk" charset="0"/>
-                        <a:cs typeface="Schibsted Grotesk" charset="0"/>
+                        <a:latin typeface="Arial" charset="0"/>
+                        <a:ea typeface="Arial" charset="0"/>
+                        <a:cs typeface="Arial" charset="0"/>
                       </a:endParaRPr>
                     </a:p>
                   </a:txBody>
@@ -2802,16 +2802,16 @@
                           <a:solidFill>
                             <a:srgbClr val="1B2240"/>
                           </a:solidFill>
-                          <a:latin typeface="Schibsted Grotesk" pitchFamily="34" charset="0"/>
-                          <a:ea typeface="Schibsted Grotesk" pitchFamily="34" charset="-122"/>
-                          <a:cs typeface="Schibsted Grotesk" pitchFamily="34" charset="-120"/>
+                          <a:latin typeface="Arial" pitchFamily="34" charset="0"/>
+                          <a:ea typeface="Arial" pitchFamily="34" charset="-122"/>
+                          <a:cs typeface="Arial" pitchFamily="34" charset="-120"/>
                         </a:rPr>
                         <a:t>Choice</a:t>
                       </a:r>
                       <a:endParaRPr lang="en-US" sz="1300" dirty="0">
-                        <a:latin typeface="Schibsted Grotesk" charset="0"/>
-                        <a:ea typeface="Schibsted Grotesk" charset="0"/>
-                        <a:cs typeface="Schibsted Grotesk" charset="0"/>
+                        <a:latin typeface="Arial" charset="0"/>
+                        <a:ea typeface="Arial" charset="0"/>
+                        <a:cs typeface="Arial" charset="0"/>
                       </a:endParaRPr>
                     </a:p>
                   </a:txBody>
@@ -2858,7 +2858,7 @@
                   </a:tcPr>
                 </a:tc>
               </a:tr>
-              <a:tr h="457200">
+              <a:tr h="658368">
                 <a:tc>
                   <a:txBody>
                     <a:bodyPr/>
@@ -2872,16 +2872,16 @@
                           <a:solidFill>
                             <a:srgbClr val="5E6785"/>
                           </a:solidFill>
-                          <a:latin typeface="IBM Plex Sans" pitchFamily="34" charset="0"/>
-                          <a:ea typeface="IBM Plex Sans" pitchFamily="34" charset="-122"/>
-                          <a:cs typeface="IBM Plex Sans" pitchFamily="34" charset="-120"/>
+                          <a:latin typeface="Arial" pitchFamily="34" charset="0"/>
+                          <a:ea typeface="Arial" pitchFamily="34" charset="-122"/>
+                          <a:cs typeface="Arial" pitchFamily="34" charset="-120"/>
                         </a:rPr>
                         <a:t>Frontend</a:t>
                       </a:r>
                       <a:endParaRPr lang="en-US" sz="1300" dirty="0">
-                        <a:latin typeface="IBM Plex Sans" charset="0"/>
-                        <a:ea typeface="IBM Plex Sans" charset="0"/>
-                        <a:cs typeface="IBM Plex Sans" charset="0"/>
+                        <a:latin typeface="Arial" charset="0"/>
+                        <a:ea typeface="Arial" charset="0"/>
+                        <a:cs typeface="Arial" charset="0"/>
                       </a:endParaRPr>
                     </a:p>
                   </a:txBody>
@@ -2937,16 +2937,16 @@
                           <a:solidFill>
                             <a:srgbClr val="5E6785"/>
                           </a:solidFill>
-                          <a:latin typeface="IBM Plex Sans" pitchFamily="34" charset="0"/>
-                          <a:ea typeface="IBM Plex Sans" pitchFamily="34" charset="-122"/>
-                          <a:cs typeface="IBM Plex Sans" pitchFamily="34" charset="-120"/>
+                          <a:latin typeface="Arial" pitchFamily="34" charset="0"/>
+                          <a:ea typeface="Arial" pitchFamily="34" charset="-122"/>
+                          <a:cs typeface="Arial" pitchFamily="34" charset="-120"/>
                         </a:rPr>
                         <a:t>Next.js 14 App Router, TypeScript strict, Tailwind with a custom token system, Recharts</a:t>
                       </a:r>
                       <a:endParaRPr lang="en-US" sz="1300" dirty="0">
-                        <a:latin typeface="IBM Plex Sans" charset="0"/>
-                        <a:ea typeface="IBM Plex Sans" charset="0"/>
-                        <a:cs typeface="IBM Plex Sans" charset="0"/>
+                        <a:latin typeface="Arial" charset="0"/>
+                        <a:ea typeface="Arial" charset="0"/>
+                        <a:cs typeface="Arial" charset="0"/>
                       </a:endParaRPr>
                     </a:p>
                   </a:txBody>
@@ -2990,7 +2990,7 @@
                   </a:tcPr>
                 </a:tc>
               </a:tr>
-              <a:tr h="457200">
+              <a:tr h="658368">
                 <a:tc>
                   <a:txBody>
                     <a:bodyPr/>
@@ -3004,16 +3004,16 @@
                           <a:solidFill>
                             <a:srgbClr val="5E6785"/>
                           </a:solidFill>
-                          <a:latin typeface="IBM Plex Sans" pitchFamily="34" charset="0"/>
-                          <a:ea typeface="IBM Plex Sans" pitchFamily="34" charset="-122"/>
-                          <a:cs typeface="IBM Plex Sans" pitchFamily="34" charset="-120"/>
+                          <a:latin typeface="Arial" pitchFamily="34" charset="0"/>
+                          <a:ea typeface="Arial" pitchFamily="34" charset="-122"/>
+                          <a:cs typeface="Arial" pitchFamily="34" charset="-120"/>
                         </a:rPr>
                         <a:t>Agent</a:t>
                       </a:r>
                       <a:endParaRPr lang="en-US" sz="1300" dirty="0">
-                        <a:latin typeface="IBM Plex Sans" charset="0"/>
-                        <a:ea typeface="IBM Plex Sans" charset="0"/>
-                        <a:cs typeface="IBM Plex Sans" charset="0"/>
+                        <a:latin typeface="Arial" charset="0"/>
+                        <a:ea typeface="Arial" charset="0"/>
+                        <a:cs typeface="Arial" charset="0"/>
                       </a:endParaRPr>
                     </a:p>
                   </a:txBody>
@@ -3069,16 +3069,16 @@
                           <a:solidFill>
                             <a:srgbClr val="5E6785"/>
                           </a:solidFill>
-                          <a:latin typeface="IBM Plex Sans" pitchFamily="34" charset="0"/>
-                          <a:ea typeface="IBM Plex Sans" pitchFamily="34" charset="-122"/>
-                          <a:cs typeface="IBM Plex Sans" pitchFamily="34" charset="-120"/>
+                          <a:latin typeface="Arial" pitchFamily="34" charset="0"/>
+                          <a:ea typeface="Arial" pitchFamily="34" charset="-122"/>
+                          <a:cs typeface="Arial" pitchFamily="34" charset="-120"/>
                         </a:rPr>
                         <a:t>Resume and GitHub ingestion, 84 skill taxonomy, deterministic scoring and planner</a:t>
                       </a:r>
                       <a:endParaRPr lang="en-US" sz="1300" dirty="0">
-                        <a:latin typeface="IBM Plex Sans" charset="0"/>
-                        <a:ea typeface="IBM Plex Sans" charset="0"/>
-                        <a:cs typeface="IBM Plex Sans" charset="0"/>
+                        <a:latin typeface="Arial" charset="0"/>
+                        <a:ea typeface="Arial" charset="0"/>
+                        <a:cs typeface="Arial" charset="0"/>
                       </a:endParaRPr>
                     </a:p>
                   </a:txBody>
@@ -3122,7 +3122,7 @@
                   </a:tcPr>
                 </a:tc>
               </a:tr>
-              <a:tr h="457200">
+              <a:tr h="658368">
                 <a:tc>
                   <a:txBody>
                     <a:bodyPr/>
@@ -3136,16 +3136,16 @@
                           <a:solidFill>
                             <a:srgbClr val="5E6785"/>
                           </a:solidFill>
-                          <a:latin typeface="IBM Plex Sans" pitchFamily="34" charset="0"/>
-                          <a:ea typeface="IBM Plex Sans" pitchFamily="34" charset="-122"/>
-                          <a:cs typeface="IBM Plex Sans" pitchFamily="34" charset="-120"/>
+                          <a:latin typeface="Arial" pitchFamily="34" charset="0"/>
+                          <a:ea typeface="Arial" pitchFamily="34" charset="-122"/>
+                          <a:cs typeface="Arial" pitchFamily="34" charset="-120"/>
                         </a:rPr>
                         <a:t>Models</a:t>
                       </a:r>
                       <a:endParaRPr lang="en-US" sz="1300" dirty="0">
-                        <a:latin typeface="IBM Plex Sans" charset="0"/>
-                        <a:ea typeface="IBM Plex Sans" charset="0"/>
-                        <a:cs typeface="IBM Plex Sans" charset="0"/>
+                        <a:latin typeface="Arial" charset="0"/>
+                        <a:ea typeface="Arial" charset="0"/>
+                        <a:cs typeface="Arial" charset="0"/>
                       </a:endParaRPr>
                     </a:p>
                   </a:txBody>
@@ -3201,16 +3201,16 @@
                           <a:solidFill>
                             <a:srgbClr val="5E6785"/>
                           </a:solidFill>
-                          <a:latin typeface="IBM Plex Sans" pitchFamily="34" charset="0"/>
-                          <a:ea typeface="IBM Plex Sans" pitchFamily="34" charset="-122"/>
-                          <a:cs typeface="IBM Plex Sans" pitchFamily="34" charset="-120"/>
+                          <a:latin typeface="Arial" pitchFamily="34" charset="0"/>
+                          <a:ea typeface="Arial" pitchFamily="34" charset="-122"/>
+                          <a:cs typeface="Arial" pitchFamily="34" charset="-120"/>
                         </a:rPr>
-                        <a:t>Sarvam AI sarvam-105b, then Groq gpt-oss-120b, then Gemini 3.8 Flash</a:t>
+                        <a:t>Sarvam AI sarvam-105b-conversations, then Groq gpt-oss-120b, then Gemini 3.8 Flash</a:t>
                       </a:r>
                       <a:endParaRPr lang="en-US" sz="1300" dirty="0">
-                        <a:latin typeface="IBM Plex Sans" charset="0"/>
-                        <a:ea typeface="IBM Plex Sans" charset="0"/>
-                        <a:cs typeface="IBM Plex Sans" charset="0"/>
+                        <a:latin typeface="Arial" charset="0"/>
+                        <a:ea typeface="Arial" charset="0"/>
+                        <a:cs typeface="Arial" charset="0"/>
                       </a:endParaRPr>
                     </a:p>
                   </a:txBody>
@@ -3254,7 +3254,7 @@
                   </a:tcPr>
                 </a:tc>
               </a:tr>
-              <a:tr h="457200">
+              <a:tr h="658368">
                 <a:tc>
                   <a:txBody>
                     <a:bodyPr/>
@@ -3268,16 +3268,16 @@
                           <a:solidFill>
                             <a:srgbClr val="5E6785"/>
                           </a:solidFill>
-                          <a:latin typeface="IBM Plex Sans" pitchFamily="34" charset="0"/>
-                          <a:ea typeface="IBM Plex Sans" pitchFamily="34" charset="-122"/>
-                          <a:cs typeface="IBM Plex Sans" pitchFamily="34" charset="-120"/>
+                          <a:latin typeface="Arial" pitchFamily="34" charset="0"/>
+                          <a:ea typeface="Arial" pitchFamily="34" charset="-122"/>
+                          <a:cs typeface="Arial" pitchFamily="34" charset="-120"/>
                         </a:rPr>
                         <a:t>Data</a:t>
                       </a:r>
                       <a:endParaRPr lang="en-US" sz="1300" dirty="0">
-                        <a:latin typeface="IBM Plex Sans" charset="0"/>
-                        <a:ea typeface="IBM Plex Sans" charset="0"/>
-                        <a:cs typeface="IBM Plex Sans" charset="0"/>
+                        <a:latin typeface="Arial" charset="0"/>
+                        <a:ea typeface="Arial" charset="0"/>
+                        <a:cs typeface="Arial" charset="0"/>
                       </a:endParaRPr>
                     </a:p>
                   </a:txBody>
@@ -3333,16 +3333,16 @@
                           <a:solidFill>
                             <a:srgbClr val="5E6785"/>
                           </a:solidFill>
-                          <a:latin typeface="IBM Plex Sans" pitchFamily="34" charset="0"/>
-                          <a:ea typeface="IBM Plex Sans" pitchFamily="34" charset="-122"/>
-                          <a:cs typeface="IBM Plex Sans" pitchFamily="34" charset="-120"/>
+                          <a:latin typeface="Arial" pitchFamily="34" charset="0"/>
+                          <a:ea typeface="Arial" pitchFamily="34" charset="-122"/>
+                          <a:cs typeface="Arial" pitchFamily="34" charset="-120"/>
                         </a:rPr>
                         <a:t>Supabase Postgres in Mumbai, local JSON store when unconfigured</a:t>
                       </a:r>
                       <a:endParaRPr lang="en-US" sz="1300" dirty="0">
-                        <a:latin typeface="IBM Plex Sans" charset="0"/>
-                        <a:ea typeface="IBM Plex Sans" charset="0"/>
-                        <a:cs typeface="IBM Plex Sans" charset="0"/>
+                        <a:latin typeface="Arial" charset="0"/>
+                        <a:ea typeface="Arial" charset="0"/>
+                        <a:cs typeface="Arial" charset="0"/>
                       </a:endParaRPr>
                     </a:p>
                   </a:txBody>
@@ -3386,7 +3386,7 @@
                   </a:tcPr>
                 </a:tc>
               </a:tr>
-              <a:tr h="457200">
+              <a:tr h="658368">
                 <a:tc>
                   <a:txBody>
                     <a:bodyPr/>
@@ -3400,16 +3400,16 @@
                           <a:solidFill>
                             <a:srgbClr val="5E6785"/>
                           </a:solidFill>
-                          <a:latin typeface="IBM Plex Sans" pitchFamily="34" charset="0"/>
-                          <a:ea typeface="IBM Plex Sans" pitchFamily="34" charset="-122"/>
-                          <a:cs typeface="IBM Plex Sans" pitchFamily="34" charset="-120"/>
+                          <a:latin typeface="Arial" pitchFamily="34" charset="0"/>
+                          <a:ea typeface="Arial" pitchFamily="34" charset="-122"/>
+                          <a:cs typeface="Arial" pitchFamily="34" charset="-120"/>
                         </a:rPr>
                         <a:t>Quality</a:t>
                       </a:r>
                       <a:endParaRPr lang="en-US" sz="1300" dirty="0">
-                        <a:latin typeface="IBM Plex Sans" charset="0"/>
-                        <a:ea typeface="IBM Plex Sans" charset="0"/>
-                        <a:cs typeface="IBM Plex Sans" charset="0"/>
+                        <a:latin typeface="Arial" charset="0"/>
+                        <a:ea typeface="Arial" charset="0"/>
+                        <a:cs typeface="Arial" charset="0"/>
                       </a:endParaRPr>
                     </a:p>
                   </a:txBody>
@@ -3465,16 +3465,16 @@
                           <a:solidFill>
                             <a:srgbClr val="5E6785"/>
                           </a:solidFill>
-                          <a:latin typeface="IBM Plex Sans" pitchFamily="34" charset="0"/>
-                          <a:ea typeface="IBM Plex Sans" pitchFamily="34" charset="-122"/>
-                          <a:cs typeface="IBM Plex Sans" pitchFamily="34" charset="-120"/>
+                          <a:latin typeface="Arial" pitchFamily="34" charset="0"/>
+                          <a:ea typeface="Arial" pitchFamily="34" charset="-122"/>
+                          <a:cs typeface="Arial" pitchFamily="34" charset="-120"/>
                         </a:rPr>
                         <a:t>69 unit tests, typecheck, lint and build in GitHub Actions</a:t>
                       </a:r>
                       <a:endParaRPr lang="en-US" sz="1300" dirty="0">
-                        <a:latin typeface="IBM Plex Sans" charset="0"/>
-                        <a:ea typeface="IBM Plex Sans" charset="0"/>
-                        <a:cs typeface="IBM Plex Sans" charset="0"/>
+                        <a:latin typeface="Arial" charset="0"/>
+                        <a:ea typeface="Arial" charset="0"/>
+                        <a:cs typeface="Arial" charset="0"/>
                       </a:endParaRPr>
                     </a:p>
                   </a:txBody>
@@ -3607,9 +3607,9 @@
                 <a:solidFill>
                   <a:srgbClr val="1B2240"/>
                 </a:solidFill>
-                <a:latin typeface="Schibsted Grotesk" pitchFamily="34" charset="0"/>
-                <a:ea typeface="Schibsted Grotesk" pitchFamily="34" charset="-122"/>
-                <a:cs typeface="Schibsted Grotesk" pitchFamily="34" charset="-120"/>
+                <a:latin typeface="Arial" pitchFamily="34" charset="0"/>
+                <a:ea typeface="Arial" pitchFamily="34" charset="-122"/>
+                <a:cs typeface="Arial" pitchFamily="34" charset="-120"/>
               </a:rPr>
               <a:t>SkillProof</a:t>
             </a:r>
@@ -3646,9 +3646,9 @@
                 <a:solidFill>
                   <a:srgbClr val="1B2240"/>
                 </a:solidFill>
-                <a:latin typeface="Schibsted Grotesk" pitchFamily="34" charset="0"/>
-                <a:ea typeface="Schibsted Grotesk" pitchFamily="34" charset="-122"/>
-                <a:cs typeface="Schibsted Grotesk" pitchFamily="34" charset="-120"/>
+                <a:latin typeface="Arial" pitchFamily="34" charset="0"/>
+                <a:ea typeface="Arial" pitchFamily="34" charset="-122"/>
+                <a:cs typeface="Arial" pitchFamily="34" charset="-120"/>
               </a:rPr>
               <a:t>Impact and what is next</a:t>
             </a:r>
@@ -3705,9 +3705,9 @@
                 <a:solidFill>
                   <a:srgbClr val="1B2240"/>
                 </a:solidFill>
-                <a:latin typeface="Schibsted Grotesk" pitchFamily="34" charset="0"/>
-                <a:ea typeface="Schibsted Grotesk" pitchFamily="34" charset="-122"/>
-                <a:cs typeface="Schibsted Grotesk" pitchFamily="34" charset="-120"/>
+                <a:latin typeface="Arial" pitchFamily="34" charset="0"/>
+                <a:ea typeface="Arial" pitchFamily="34" charset="-122"/>
+                <a:cs typeface="Arial" pitchFamily="34" charset="-120"/>
               </a:rPr>
               <a:t>For a student</a:t>
             </a:r>
@@ -3744,9 +3744,9 @@
                 <a:solidFill>
                   <a:srgbClr val="5E6785"/>
                 </a:solidFill>
-                <a:latin typeface="IBM Plex Sans" pitchFamily="34" charset="0"/>
-                <a:ea typeface="IBM Plex Sans" pitchFamily="34" charset="-122"/>
-                <a:cs typeface="IBM Plex Sans" pitchFamily="34" charset="-120"/>
+                <a:latin typeface="Arial" pitchFamily="34" charset="0"/>
+                <a:ea typeface="Arial" pitchFamily="34" charset="-122"/>
+                <a:cs typeface="Arial" pitchFamily="34" charset="-120"/>
               </a:rPr>
               <a:t>one number to argue with, a ranked list of what to fix, a portfolio project per gap</a:t>
             </a:r>
@@ -3803,9 +3803,9 @@
                 <a:solidFill>
                   <a:srgbClr val="1B2240"/>
                 </a:solidFill>
-                <a:latin typeface="Schibsted Grotesk" pitchFamily="34" charset="0"/>
-                <a:ea typeface="Schibsted Grotesk" pitchFamily="34" charset="-122"/>
-                <a:cs typeface="Schibsted Grotesk" pitchFamily="34" charset="-120"/>
+                <a:latin typeface="Arial" pitchFamily="34" charset="0"/>
+                <a:ea typeface="Arial" pitchFamily="34" charset="-122"/>
+                <a:cs typeface="Arial" pitchFamily="34" charset="-120"/>
               </a:rPr>
               <a:t>For a placement cell</a:t>
             </a:r>
@@ -3842,9 +3842,9 @@
                 <a:solidFill>
                   <a:srgbClr val="5E6785"/>
                 </a:solidFill>
-                <a:latin typeface="IBM Plex Sans" pitchFamily="34" charset="0"/>
-                <a:ea typeface="IBM Plex Sans" pitchFamily="34" charset="-122"/>
-                <a:cs typeface="IBM Plex Sans" pitchFamily="34" charset="-120"/>
+                <a:latin typeface="Arial" pitchFamily="34" charset="0"/>
+                <a:ea typeface="Arial" pitchFamily="34" charset="-122"/>
+                <a:cs typeface="Arial" pitchFamily="34" charset="-120"/>
               </a:rPr>
               <a:t>the same engine across a cohort shows where training should actually go</a:t>
             </a:r>
@@ -3901,9 +3901,9 @@
                 <a:solidFill>
                   <a:srgbClr val="1B2240"/>
                 </a:solidFill>
-                <a:latin typeface="Schibsted Grotesk" pitchFamily="34" charset="0"/>
-                <a:ea typeface="Schibsted Grotesk" pitchFamily="34" charset="-122"/>
-                <a:cs typeface="Schibsted Grotesk" pitchFamily="34" charset="-120"/>
+                <a:latin typeface="Arial" pitchFamily="34" charset="0"/>
+                <a:ea typeface="Arial" pitchFamily="34" charset="-122"/>
+                <a:cs typeface="Arial" pitchFamily="34" charset="-120"/>
               </a:rPr>
               <a:t>Next</a:t>
             </a:r>
@@ -3940,9 +3940,9 @@
                 <a:solidFill>
                   <a:srgbClr val="5E6785"/>
                 </a:solidFill>
-                <a:latin typeface="IBM Plex Sans" pitchFamily="34" charset="0"/>
-                <a:ea typeface="IBM Plex Sans" pitchFamily="34" charset="-122"/>
-                <a:cs typeface="IBM Plex Sans" pitchFamily="34" charset="-120"/>
+                <a:latin typeface="Arial" pitchFamily="34" charset="0"/>
+                <a:ea typeface="Arial" pitchFamily="34" charset="-122"/>
+                <a:cs typeface="Arial" pitchFamily="34" charset="-120"/>
               </a:rPr>
               <a:t>live job description ingestion, Hindi interface, mentor review as a fourth evidence level</a:t>
             </a:r>
@@ -4002,9 +4002,9 @@
                 <a:solidFill>
                   <a:srgbClr val="5E6785"/>
                 </a:solidFill>
-                <a:latin typeface="IBM Plex Sans" pitchFamily="34" charset="0"/>
-                <a:ea typeface="IBM Plex Sans" pitchFamily="34" charset="-122"/>
-                <a:cs typeface="IBM Plex Sans" pitchFamily="34" charset="-120"/>
+                <a:latin typeface="Arial" pitchFamily="34" charset="0"/>
+                <a:ea typeface="Arial" pitchFamily="34" charset="-122"/>
+                <a:cs typeface="Arial" pitchFamily="34" charset="-120"/>
               </a:rPr>
               <a:t>Live demo  </a:t>
             </a:r>
@@ -4019,9 +4019,9 @@
                 <a:solidFill>
                   <a:srgbClr val="2F4BFF"/>
                 </a:solidFill>
-                <a:latin typeface="IBM Plex Sans" pitchFamily="34" charset="0"/>
-                <a:ea typeface="IBM Plex Sans" pitchFamily="34" charset="-122"/>
-                <a:cs typeface="IBM Plex Sans" pitchFamily="34" charset="-120"/>
+                <a:latin typeface="Arial" pitchFamily="34" charset="0"/>
+                <a:ea typeface="Arial" pitchFamily="34" charset="-122"/>
+                <a:cs typeface="Arial" pitchFamily="34" charset="-120"/>
               </a:rPr>
               <a:t>https://skillproof.vercel.app</a:t>
             </a:r>
@@ -4045,9 +4045,9 @@
                 <a:solidFill>
                   <a:srgbClr val="5E6785"/>
                 </a:solidFill>
-                <a:latin typeface="IBM Plex Sans" pitchFamily="34" charset="0"/>
-                <a:ea typeface="IBM Plex Sans" pitchFamily="34" charset="-122"/>
-                <a:cs typeface="IBM Plex Sans" pitchFamily="34" charset="-120"/>
+                <a:latin typeface="Arial" pitchFamily="34" charset="0"/>
+                <a:ea typeface="Arial" pitchFamily="34" charset="-122"/>
+                <a:cs typeface="Arial" pitchFamily="34" charset="-120"/>
               </a:rPr>
               <a:t>Source  </a:t>
             </a:r>
@@ -4065,9 +4065,9 @@
                 <a:solidFill>
                   <a:srgbClr val="2F4BFF"/>
                 </a:solidFill>
-                <a:latin typeface="IBM Plex Sans" pitchFamily="34" charset="0"/>
-                <a:ea typeface="IBM Plex Sans" pitchFamily="34" charset="-122"/>
-                <a:cs typeface="IBM Plex Sans" pitchFamily="34" charset="-120"/>
+                <a:latin typeface="Arial" pitchFamily="34" charset="0"/>
+                <a:ea typeface="Arial" pitchFamily="34" charset="-122"/>
+                <a:cs typeface="Arial" pitchFamily="34" charset="-120"/>
               </a:rPr>
               <a:t>https://github.com/shubhamverma-devx/skillproof</a:t>
             </a:r>
@@ -4160,9 +4160,9 @@
                 <a:solidFill>
                   <a:srgbClr val="1B2240"/>
                 </a:solidFill>
-                <a:latin typeface="Schibsted Grotesk" pitchFamily="34" charset="0"/>
-                <a:ea typeface="Schibsted Grotesk" pitchFamily="34" charset="-122"/>
-                <a:cs typeface="Schibsted Grotesk" pitchFamily="34" charset="-120"/>
+                <a:latin typeface="Arial" pitchFamily="34" charset="0"/>
+                <a:ea typeface="Arial" pitchFamily="34" charset="-122"/>
+                <a:cs typeface="Arial" pitchFamily="34" charset="-120"/>
               </a:rPr>
               <a:t>SkillProof</a:t>
             </a:r>
@@ -4199,9 +4199,9 @@
                 <a:solidFill>
                   <a:srgbClr val="1B2240"/>
                 </a:solidFill>
-                <a:latin typeface="Schibsted Grotesk" pitchFamily="34" charset="0"/>
-                <a:ea typeface="Schibsted Grotesk" pitchFamily="34" charset="-122"/>
-                <a:cs typeface="Schibsted Grotesk" pitchFamily="34" charset="-120"/>
+                <a:latin typeface="Arial" pitchFamily="34" charset="0"/>
+                <a:ea typeface="Arial" pitchFamily="34" charset="-122"/>
+                <a:cs typeface="Arial" pitchFamily="34" charset="-120"/>
               </a:rPr>
               <a:t>The problem</a:t>
             </a:r>
@@ -4238,9 +4238,9 @@
                 <a:solidFill>
                   <a:srgbClr val="5E6785"/>
                 </a:solidFill>
-                <a:latin typeface="IBM Plex Sans" pitchFamily="34" charset="0"/>
-                <a:ea typeface="IBM Plex Sans" pitchFamily="34" charset="-122"/>
-                <a:cs typeface="IBM Plex Sans" pitchFamily="34" charset="-120"/>
+                <a:latin typeface="Arial" pitchFamily="34" charset="0"/>
+                <a:ea typeface="Arial" pitchFamily="34" charset="-122"/>
+                <a:cs typeface="Arial" pitchFamily="34" charset="-120"/>
               </a:rPr>
               <a:t>A student knows the role they want. Nobody tells them what they are missing for it.</a:t>
             </a:r>
@@ -4297,9 +4297,9 @@
                 <a:solidFill>
                   <a:srgbClr val="1B2240"/>
                 </a:solidFill>
-                <a:latin typeface="Schibsted Grotesk" pitchFamily="34" charset="0"/>
-                <a:ea typeface="Schibsted Grotesk" pitchFamily="34" charset="-122"/>
-                <a:cs typeface="Schibsted Grotesk" pitchFamily="34" charset="-120"/>
+                <a:latin typeface="Arial" pitchFamily="34" charset="0"/>
+                <a:ea typeface="Arial" pitchFamily="34" charset="-122"/>
+                <a:cs typeface="Arial" pitchFamily="34" charset="-120"/>
               </a:rPr>
               <a:t>Resumes are self reported</a:t>
             </a:r>
@@ -4336,9 +4336,9 @@
                 <a:solidFill>
                   <a:srgbClr val="5E6785"/>
                 </a:solidFill>
-                <a:latin typeface="IBM Plex Sans" pitchFamily="34" charset="0"/>
-                <a:ea typeface="IBM Plex Sans" pitchFamily="34" charset="-122"/>
-                <a:cs typeface="IBM Plex Sans" pitchFamily="34" charset="-120"/>
+                <a:latin typeface="Arial" pitchFamily="34" charset="0"/>
+                <a:ea typeface="Arial" pitchFamily="34" charset="-122"/>
+                <a:cs typeface="Arial" pitchFamily="34" charset="-120"/>
               </a:rPr>
               <a:t>a listed skill and a proven skill look identical on paper</a:t>
             </a:r>
@@ -4395,9 +4395,9 @@
                 <a:solidFill>
                   <a:srgbClr val="1B2240"/>
                 </a:solidFill>
-                <a:latin typeface="Schibsted Grotesk" pitchFamily="34" charset="0"/>
-                <a:ea typeface="Schibsted Grotesk" pitchFamily="34" charset="-122"/>
-                <a:cs typeface="Schibsted Grotesk" pitchFamily="34" charset="-120"/>
+                <a:latin typeface="Arial" pitchFamily="34" charset="0"/>
+                <a:ea typeface="Arial" pitchFamily="34" charset="-122"/>
+                <a:cs typeface="Arial" pitchFamily="34" charset="-120"/>
               </a:rPr>
               <a:t>Roadmaps are generic</a:t>
             </a:r>
@@ -4434,9 +4434,9 @@
                 <a:solidFill>
                   <a:srgbClr val="5E6785"/>
                 </a:solidFill>
-                <a:latin typeface="IBM Plex Sans" pitchFamily="34" charset="0"/>
-                <a:ea typeface="IBM Plex Sans" pitchFamily="34" charset="-122"/>
-                <a:cs typeface="IBM Plex Sans" pitchFamily="34" charset="-120"/>
+                <a:latin typeface="Arial" pitchFamily="34" charset="0"/>
+                <a:ea typeface="Arial" pitchFamily="34" charset="-122"/>
+                <a:cs typeface="Arial" pitchFamily="34" charset="-120"/>
               </a:rPr>
               <a:t>the same eight week plan for a student with four shipped projects and one with none</a:t>
             </a:r>
@@ -4493,9 +4493,9 @@
                 <a:solidFill>
                   <a:srgbClr val="1B2240"/>
                 </a:solidFill>
-                <a:latin typeface="Schibsted Grotesk" pitchFamily="34" charset="0"/>
-                <a:ea typeface="Schibsted Grotesk" pitchFamily="34" charset="-122"/>
-                <a:cs typeface="Schibsted Grotesk" pitchFamily="34" charset="-120"/>
+                <a:latin typeface="Arial" pitchFamily="34" charset="0"/>
+                <a:ea typeface="Arial" pitchFamily="34" charset="-122"/>
+                <a:cs typeface="Arial" pitchFamily="34" charset="-120"/>
               </a:rPr>
               <a:t>Nothing is measurable</a:t>
             </a:r>
@@ -4532,9 +4532,9 @@
                 <a:solidFill>
                   <a:srgbClr val="5E6785"/>
                 </a:solidFill>
-                <a:latin typeface="IBM Plex Sans" pitchFamily="34" charset="0"/>
-                <a:ea typeface="IBM Plex Sans" pitchFamily="34" charset="-122"/>
-                <a:cs typeface="IBM Plex Sans" pitchFamily="34" charset="-120"/>
+                <a:latin typeface="Arial" pitchFamily="34" charset="0"/>
+                <a:ea typeface="Arial" pitchFamily="34" charset="-122"/>
+                <a:cs typeface="Arial" pitchFamily="34" charset="-120"/>
               </a:rPr>
               <a:t>no number to argue with, so no way to know if this month helped</a:t>
             </a:r>
@@ -4591,9 +4591,9 @@
                 <a:solidFill>
                   <a:srgbClr val="1B2240"/>
                 </a:solidFill>
-                <a:latin typeface="Schibsted Grotesk" pitchFamily="34" charset="0"/>
-                <a:ea typeface="Schibsted Grotesk" pitchFamily="34" charset="-122"/>
-                <a:cs typeface="Schibsted Grotesk" pitchFamily="34" charset="-120"/>
+                <a:latin typeface="Arial" pitchFamily="34" charset="0"/>
+                <a:ea typeface="Arial" pitchFamily="34" charset="-122"/>
+                <a:cs typeface="Arial" pitchFamily="34" charset="-120"/>
               </a:rPr>
               <a:t>The result</a:t>
             </a:r>
@@ -4630,9 +4630,9 @@
                 <a:solidFill>
                   <a:srgbClr val="5E6785"/>
                 </a:solidFill>
-                <a:latin typeface="IBM Plex Sans" pitchFamily="34" charset="0"/>
-                <a:ea typeface="IBM Plex Sans" pitchFamily="34" charset="-122"/>
-                <a:cs typeface="IBM Plex Sans" pitchFamily="34" charset="-120"/>
+                <a:latin typeface="Arial" pitchFamily="34" charset="0"/>
+                <a:ea typeface="Arial" pitchFamily="34" charset="-122"/>
+                <a:cs typeface="Arial" pitchFamily="34" charset="-120"/>
               </a:rPr>
               <a:t>months on the wrong skill, and a portfolio that does not answer the recruiter question</a:t>
             </a:r>
@@ -4725,9 +4725,9 @@
                 <a:solidFill>
                   <a:srgbClr val="1B2240"/>
                 </a:solidFill>
-                <a:latin typeface="Schibsted Grotesk" pitchFamily="34" charset="0"/>
-                <a:ea typeface="Schibsted Grotesk" pitchFamily="34" charset="-122"/>
-                <a:cs typeface="Schibsted Grotesk" pitchFamily="34" charset="-120"/>
+                <a:latin typeface="Arial" pitchFamily="34" charset="0"/>
+                <a:ea typeface="Arial" pitchFamily="34" charset="-122"/>
+                <a:cs typeface="Arial" pitchFamily="34" charset="-120"/>
               </a:rPr>
               <a:t>SkillProof</a:t>
             </a:r>
@@ -4764,9 +4764,9 @@
                 <a:solidFill>
                   <a:srgbClr val="1B2240"/>
                 </a:solidFill>
-                <a:latin typeface="Schibsted Grotesk" pitchFamily="34" charset="0"/>
-                <a:ea typeface="Schibsted Grotesk" pitchFamily="34" charset="-122"/>
-                <a:cs typeface="Schibsted Grotesk" pitchFamily="34" charset="-120"/>
+                <a:latin typeface="Arial" pitchFamily="34" charset="0"/>
+                <a:ea typeface="Arial" pitchFamily="34" charset="-122"/>
+                <a:cs typeface="Arial" pitchFamily="34" charset="-120"/>
               </a:rPr>
               <a:t>Why existing tools fall short</a:t>
             </a:r>
@@ -4789,7 +4789,7 @@
           </p:nvPr>
         </p:nvGraphicFramePr>
         <p:xfrm>
-          <a:off x="502920" y="2103120"/>
+          <a:off x="502920" y="2194560"/>
           <a:ext cx="11183112" cy="914400"/>
         </p:xfrm>
         <a:graphic>
@@ -4801,7 +4801,7 @@
                 <a:gridCol w="3727704"/>
                 <a:gridCol w="3727704"/>
               </a:tblGrid>
-              <a:tr h="457200">
+              <a:tr h="658368">
                 <a:tc>
                   <a:txBody>
                     <a:bodyPr/>
@@ -4815,16 +4815,16 @@
                           <a:solidFill>
                             <a:srgbClr val="1B2240"/>
                           </a:solidFill>
-                          <a:latin typeface="Schibsted Grotesk" pitchFamily="34" charset="0"/>
-                          <a:ea typeface="Schibsted Grotesk" pitchFamily="34" charset="-122"/>
-                          <a:cs typeface="Schibsted Grotesk" pitchFamily="34" charset="-120"/>
+                          <a:latin typeface="Arial" pitchFamily="34" charset="0"/>
+                          <a:ea typeface="Arial" pitchFamily="34" charset="-122"/>
+                          <a:cs typeface="Arial" pitchFamily="34" charset="-120"/>
                         </a:rPr>
                         <a:t>Tool</a:t>
                       </a:r>
                       <a:endParaRPr lang="en-US" sz="1300" dirty="0">
-                        <a:latin typeface="Schibsted Grotesk" charset="0"/>
-                        <a:ea typeface="Schibsted Grotesk" charset="0"/>
-                        <a:cs typeface="Schibsted Grotesk" charset="0"/>
+                        <a:latin typeface="Arial" charset="0"/>
+                        <a:ea typeface="Arial" charset="0"/>
+                        <a:cs typeface="Arial" charset="0"/>
                       </a:endParaRPr>
                     </a:p>
                   </a:txBody>
@@ -4883,16 +4883,16 @@
                           <a:solidFill>
                             <a:srgbClr val="1B2240"/>
                           </a:solidFill>
-                          <a:latin typeface="Schibsted Grotesk" pitchFamily="34" charset="0"/>
-                          <a:ea typeface="Schibsted Grotesk" pitchFamily="34" charset="-122"/>
-                          <a:cs typeface="Schibsted Grotesk" pitchFamily="34" charset="-120"/>
+                          <a:latin typeface="Arial" pitchFamily="34" charset="0"/>
+                          <a:ea typeface="Arial" pitchFamily="34" charset="-122"/>
+                          <a:cs typeface="Arial" pitchFamily="34" charset="-120"/>
                         </a:rPr>
                         <a:t>What it does</a:t>
                       </a:r>
                       <a:endParaRPr lang="en-US" sz="1300" dirty="0">
-                        <a:latin typeface="Schibsted Grotesk" charset="0"/>
-                        <a:ea typeface="Schibsted Grotesk" charset="0"/>
-                        <a:cs typeface="Schibsted Grotesk" charset="0"/>
+                        <a:latin typeface="Arial" charset="0"/>
+                        <a:ea typeface="Arial" charset="0"/>
+                        <a:cs typeface="Arial" charset="0"/>
                       </a:endParaRPr>
                     </a:p>
                   </a:txBody>
@@ -4951,16 +4951,16 @@
                           <a:solidFill>
                             <a:srgbClr val="1B2240"/>
                           </a:solidFill>
-                          <a:latin typeface="Schibsted Grotesk" pitchFamily="34" charset="0"/>
-                          <a:ea typeface="Schibsted Grotesk" pitchFamily="34" charset="-122"/>
-                          <a:cs typeface="Schibsted Grotesk" pitchFamily="34" charset="-120"/>
+                          <a:latin typeface="Arial" pitchFamily="34" charset="0"/>
+                          <a:ea typeface="Arial" pitchFamily="34" charset="-122"/>
+                          <a:cs typeface="Arial" pitchFamily="34" charset="-120"/>
                         </a:rPr>
                         <a:t>What it misses</a:t>
                       </a:r>
                       <a:endParaRPr lang="en-US" sz="1300" dirty="0">
-                        <a:latin typeface="Schibsted Grotesk" charset="0"/>
-                        <a:ea typeface="Schibsted Grotesk" charset="0"/>
-                        <a:cs typeface="Schibsted Grotesk" charset="0"/>
+                        <a:latin typeface="Arial" charset="0"/>
+                        <a:ea typeface="Arial" charset="0"/>
+                        <a:cs typeface="Arial" charset="0"/>
                       </a:endParaRPr>
                     </a:p>
                   </a:txBody>
@@ -5007,7 +5007,7 @@
                   </a:tcPr>
                 </a:tc>
               </a:tr>
-              <a:tr h="457200">
+              <a:tr h="658368">
                 <a:tc>
                   <a:txBody>
                     <a:bodyPr/>
@@ -5021,16 +5021,16 @@
                           <a:solidFill>
                             <a:srgbClr val="5E6785"/>
                           </a:solidFill>
-                          <a:latin typeface="IBM Plex Sans" pitchFamily="34" charset="0"/>
-                          <a:ea typeface="IBM Plex Sans" pitchFamily="34" charset="-122"/>
-                          <a:cs typeface="IBM Plex Sans" pitchFamily="34" charset="-120"/>
+                          <a:latin typeface="Arial" pitchFamily="34" charset="0"/>
+                          <a:ea typeface="Arial" pitchFamily="34" charset="-122"/>
+                          <a:cs typeface="Arial" pitchFamily="34" charset="-120"/>
                         </a:rPr>
                         <a:t>Course platforms</a:t>
                       </a:r>
                       <a:endParaRPr lang="en-US" sz="1300" dirty="0">
-                        <a:latin typeface="IBM Plex Sans" charset="0"/>
-                        <a:ea typeface="IBM Plex Sans" charset="0"/>
-                        <a:cs typeface="IBM Plex Sans" charset="0"/>
+                        <a:latin typeface="Arial" charset="0"/>
+                        <a:ea typeface="Arial" charset="0"/>
+                        <a:cs typeface="Arial" charset="0"/>
                       </a:endParaRPr>
                     </a:p>
                   </a:txBody>
@@ -5086,16 +5086,16 @@
                           <a:solidFill>
                             <a:srgbClr val="5E6785"/>
                           </a:solidFill>
-                          <a:latin typeface="IBM Plex Sans" pitchFamily="34" charset="0"/>
-                          <a:ea typeface="IBM Plex Sans" pitchFamily="34" charset="-122"/>
-                          <a:cs typeface="IBM Plex Sans" pitchFamily="34" charset="-120"/>
+                          <a:latin typeface="Arial" pitchFamily="34" charset="0"/>
+                          <a:ea typeface="Arial" pitchFamily="34" charset="-122"/>
+                          <a:cs typeface="Arial" pitchFamily="34" charset="-120"/>
                         </a:rPr>
                         <a:t>Sell a fixed syllabus</a:t>
                       </a:r>
                       <a:endParaRPr lang="en-US" sz="1300" dirty="0">
-                        <a:latin typeface="IBM Plex Sans" charset="0"/>
-                        <a:ea typeface="IBM Plex Sans" charset="0"/>
-                        <a:cs typeface="IBM Plex Sans" charset="0"/>
+                        <a:latin typeface="Arial" charset="0"/>
+                        <a:ea typeface="Arial" charset="0"/>
+                        <a:cs typeface="Arial" charset="0"/>
                       </a:endParaRPr>
                     </a:p>
                   </a:txBody>
@@ -5151,16 +5151,16 @@
                           <a:solidFill>
                             <a:srgbClr val="5E6785"/>
                           </a:solidFill>
-                          <a:latin typeface="IBM Plex Sans" pitchFamily="34" charset="0"/>
-                          <a:ea typeface="IBM Plex Sans" pitchFamily="34" charset="-122"/>
-                          <a:cs typeface="IBM Plex Sans" pitchFamily="34" charset="-120"/>
+                          <a:latin typeface="Arial" pitchFamily="34" charset="0"/>
+                          <a:ea typeface="Arial" pitchFamily="34" charset="-122"/>
+                          <a:cs typeface="Arial" pitchFamily="34" charset="-120"/>
                         </a:rPr>
                         <a:t>No idea what you already know</a:t>
                       </a:r>
                       <a:endParaRPr lang="en-US" sz="1300" dirty="0">
-                        <a:latin typeface="IBM Plex Sans" charset="0"/>
-                        <a:ea typeface="IBM Plex Sans" charset="0"/>
-                        <a:cs typeface="IBM Plex Sans" charset="0"/>
+                        <a:latin typeface="Arial" charset="0"/>
+                        <a:ea typeface="Arial" charset="0"/>
+                        <a:cs typeface="Arial" charset="0"/>
                       </a:endParaRPr>
                     </a:p>
                   </a:txBody>
@@ -5204,7 +5204,7 @@
                   </a:tcPr>
                 </a:tc>
               </a:tr>
-              <a:tr h="457200">
+              <a:tr h="658368">
                 <a:tc>
                   <a:txBody>
                     <a:bodyPr/>
@@ -5218,16 +5218,16 @@
                           <a:solidFill>
                             <a:srgbClr val="5E6785"/>
                           </a:solidFill>
-                          <a:latin typeface="IBM Plex Sans" pitchFamily="34" charset="0"/>
-                          <a:ea typeface="IBM Plex Sans" pitchFamily="34" charset="-122"/>
-                          <a:cs typeface="IBM Plex Sans" pitchFamily="34" charset="-120"/>
+                          <a:latin typeface="Arial" pitchFamily="34" charset="0"/>
+                          <a:ea typeface="Arial" pitchFamily="34" charset="-122"/>
+                          <a:cs typeface="Arial" pitchFamily="34" charset="-120"/>
                         </a:rPr>
                         <a:t>Resume scanners</a:t>
                       </a:r>
                       <a:endParaRPr lang="en-US" sz="1300" dirty="0">
-                        <a:latin typeface="IBM Plex Sans" charset="0"/>
-                        <a:ea typeface="IBM Plex Sans" charset="0"/>
-                        <a:cs typeface="IBM Plex Sans" charset="0"/>
+                        <a:latin typeface="Arial" charset="0"/>
+                        <a:ea typeface="Arial" charset="0"/>
+                        <a:cs typeface="Arial" charset="0"/>
                       </a:endParaRPr>
                     </a:p>
                   </a:txBody>
@@ -5283,16 +5283,16 @@
                           <a:solidFill>
                             <a:srgbClr val="5E6785"/>
                           </a:solidFill>
-                          <a:latin typeface="IBM Plex Sans" pitchFamily="34" charset="0"/>
-                          <a:ea typeface="IBM Plex Sans" pitchFamily="34" charset="-122"/>
-                          <a:cs typeface="IBM Plex Sans" pitchFamily="34" charset="-120"/>
+                          <a:latin typeface="Arial" pitchFamily="34" charset="0"/>
+                          <a:ea typeface="Arial" pitchFamily="34" charset="-122"/>
+                          <a:cs typeface="Arial" pitchFamily="34" charset="-120"/>
                         </a:rPr>
                         <a:t>Match keywords to a job description</a:t>
                       </a:r>
                       <a:endParaRPr lang="en-US" sz="1300" dirty="0">
-                        <a:latin typeface="IBM Plex Sans" charset="0"/>
-                        <a:ea typeface="IBM Plex Sans" charset="0"/>
-                        <a:cs typeface="IBM Plex Sans" charset="0"/>
+                        <a:latin typeface="Arial" charset="0"/>
+                        <a:ea typeface="Arial" charset="0"/>
+                        <a:cs typeface="Arial" charset="0"/>
                       </a:endParaRPr>
                     </a:p>
                   </a:txBody>
@@ -5348,16 +5348,16 @@
                           <a:solidFill>
                             <a:srgbClr val="5E6785"/>
                           </a:solidFill>
-                          <a:latin typeface="IBM Plex Sans" pitchFamily="34" charset="0"/>
-                          <a:ea typeface="IBM Plex Sans" pitchFamily="34" charset="-122"/>
-                          <a:cs typeface="IBM Plex Sans" pitchFamily="34" charset="-120"/>
+                          <a:latin typeface="Arial" pitchFamily="34" charset="0"/>
+                          <a:ea typeface="Arial" pitchFamily="34" charset="-122"/>
+                          <a:cs typeface="Arial" pitchFamily="34" charset="-120"/>
                         </a:rPr>
                         <a:t>Trusts the resume completely</a:t>
                       </a:r>
                       <a:endParaRPr lang="en-US" sz="1300" dirty="0">
-                        <a:latin typeface="IBM Plex Sans" charset="0"/>
-                        <a:ea typeface="IBM Plex Sans" charset="0"/>
-                        <a:cs typeface="IBM Plex Sans" charset="0"/>
+                        <a:latin typeface="Arial" charset="0"/>
+                        <a:ea typeface="Arial" charset="0"/>
+                        <a:cs typeface="Arial" charset="0"/>
                       </a:endParaRPr>
                     </a:p>
                   </a:txBody>
@@ -5401,7 +5401,7 @@
                   </a:tcPr>
                 </a:tc>
               </a:tr>
-              <a:tr h="457200">
+              <a:tr h="658368">
                 <a:tc>
                   <a:txBody>
                     <a:bodyPr/>
@@ -5415,16 +5415,16 @@
                           <a:solidFill>
                             <a:srgbClr val="5E6785"/>
                           </a:solidFill>
-                          <a:latin typeface="IBM Plex Sans" pitchFamily="34" charset="0"/>
-                          <a:ea typeface="IBM Plex Sans" pitchFamily="34" charset="-122"/>
-                          <a:cs typeface="IBM Plex Sans" pitchFamily="34" charset="-120"/>
+                          <a:latin typeface="Arial" pitchFamily="34" charset="0"/>
+                          <a:ea typeface="Arial" pitchFamily="34" charset="-122"/>
+                          <a:cs typeface="Arial" pitchFamily="34" charset="-120"/>
                         </a:rPr>
                         <a:t>A chatbot</a:t>
                       </a:r>
                       <a:endParaRPr lang="en-US" sz="1300" dirty="0">
-                        <a:latin typeface="IBM Plex Sans" charset="0"/>
-                        <a:ea typeface="IBM Plex Sans" charset="0"/>
-                        <a:cs typeface="IBM Plex Sans" charset="0"/>
+                        <a:latin typeface="Arial" charset="0"/>
+                        <a:ea typeface="Arial" charset="0"/>
+                        <a:cs typeface="Arial" charset="0"/>
                       </a:endParaRPr>
                     </a:p>
                   </a:txBody>
@@ -5480,16 +5480,16 @@
                           <a:solidFill>
                             <a:srgbClr val="5E6785"/>
                           </a:solidFill>
-                          <a:latin typeface="IBM Plex Sans" pitchFamily="34" charset="0"/>
-                          <a:ea typeface="IBM Plex Sans" pitchFamily="34" charset="-122"/>
-                          <a:cs typeface="IBM Plex Sans" pitchFamily="34" charset="-120"/>
+                          <a:latin typeface="Arial" pitchFamily="34" charset="0"/>
+                          <a:ea typeface="Arial" pitchFamily="34" charset="-122"/>
+                          <a:cs typeface="Arial" pitchFamily="34" charset="-120"/>
                         </a:rPr>
                         <a:t>Writes a plausible roadmap</a:t>
                       </a:r>
                       <a:endParaRPr lang="en-US" sz="1300" dirty="0">
-                        <a:latin typeface="IBM Plex Sans" charset="0"/>
-                        <a:ea typeface="IBM Plex Sans" charset="0"/>
-                        <a:cs typeface="IBM Plex Sans" charset="0"/>
+                        <a:latin typeface="Arial" charset="0"/>
+                        <a:ea typeface="Arial" charset="0"/>
+                        <a:cs typeface="Arial" charset="0"/>
                       </a:endParaRPr>
                     </a:p>
                   </a:txBody>
@@ -5545,16 +5545,16 @@
                           <a:solidFill>
                             <a:srgbClr val="5E6785"/>
                           </a:solidFill>
-                          <a:latin typeface="IBM Plex Sans" pitchFamily="34" charset="0"/>
-                          <a:ea typeface="IBM Plex Sans" pitchFamily="34" charset="-122"/>
-                          <a:cs typeface="IBM Plex Sans" pitchFamily="34" charset="-120"/>
+                          <a:latin typeface="Arial" pitchFamily="34" charset="0"/>
+                          <a:ea typeface="Arial" pitchFamily="34" charset="-122"/>
+                          <a:cs typeface="Arial" pitchFamily="34" charset="-120"/>
                         </a:rPr>
                         <a:t>No evidence, no score, no memory, invented links</a:t>
                       </a:r>
                       <a:endParaRPr lang="en-US" sz="1300" dirty="0">
-                        <a:latin typeface="IBM Plex Sans" charset="0"/>
-                        <a:ea typeface="IBM Plex Sans" charset="0"/>
-                        <a:cs typeface="IBM Plex Sans" charset="0"/>
+                        <a:latin typeface="Arial" charset="0"/>
+                        <a:ea typeface="Arial" charset="0"/>
+                        <a:cs typeface="Arial" charset="0"/>
                       </a:endParaRPr>
                     </a:p>
                   </a:txBody>
@@ -5598,7 +5598,7 @@
                   </a:tcPr>
                 </a:tc>
               </a:tr>
-              <a:tr h="457200">
+              <a:tr h="658368">
                 <a:tc>
                   <a:txBody>
                     <a:bodyPr/>
@@ -5612,16 +5612,16 @@
                           <a:solidFill>
                             <a:srgbClr val="5E6785"/>
                           </a:solidFill>
-                          <a:latin typeface="IBM Plex Sans" pitchFamily="34" charset="0"/>
-                          <a:ea typeface="IBM Plex Sans" pitchFamily="34" charset="-122"/>
-                          <a:cs typeface="IBM Plex Sans" pitchFamily="34" charset="-120"/>
+                          <a:latin typeface="Arial" pitchFamily="34" charset="0"/>
+                          <a:ea typeface="Arial" pitchFamily="34" charset="-122"/>
+                          <a:cs typeface="Arial" pitchFamily="34" charset="-120"/>
                         </a:rPr>
                         <a:t>Placement portals</a:t>
                       </a:r>
                       <a:endParaRPr lang="en-US" sz="1300" dirty="0">
-                        <a:latin typeface="IBM Plex Sans" charset="0"/>
-                        <a:ea typeface="IBM Plex Sans" charset="0"/>
-                        <a:cs typeface="IBM Plex Sans" charset="0"/>
+                        <a:latin typeface="Arial" charset="0"/>
+                        <a:ea typeface="Arial" charset="0"/>
+                        <a:cs typeface="Arial" charset="0"/>
                       </a:endParaRPr>
                     </a:p>
                   </a:txBody>
@@ -5677,16 +5677,16 @@
                           <a:solidFill>
                             <a:srgbClr val="5E6785"/>
                           </a:solidFill>
-                          <a:latin typeface="IBM Plex Sans" pitchFamily="34" charset="0"/>
-                          <a:ea typeface="IBM Plex Sans" pitchFamily="34" charset="-122"/>
-                          <a:cs typeface="IBM Plex Sans" pitchFamily="34" charset="-120"/>
+                          <a:latin typeface="Arial" pitchFamily="34" charset="0"/>
+                          <a:ea typeface="Arial" pitchFamily="34" charset="-122"/>
+                          <a:cs typeface="Arial" pitchFamily="34" charset="-120"/>
                         </a:rPr>
                         <a:t>List openings</a:t>
                       </a:r>
                       <a:endParaRPr lang="en-US" sz="1300" dirty="0">
-                        <a:latin typeface="IBM Plex Sans" charset="0"/>
-                        <a:ea typeface="IBM Plex Sans" charset="0"/>
-                        <a:cs typeface="IBM Plex Sans" charset="0"/>
+                        <a:latin typeface="Arial" charset="0"/>
+                        <a:ea typeface="Arial" charset="0"/>
+                        <a:cs typeface="Arial" charset="0"/>
                       </a:endParaRPr>
                     </a:p>
                   </a:txBody>
@@ -5742,16 +5742,16 @@
                           <a:solidFill>
                             <a:srgbClr val="5E6785"/>
                           </a:solidFill>
-                          <a:latin typeface="IBM Plex Sans" pitchFamily="34" charset="0"/>
-                          <a:ea typeface="IBM Plex Sans" pitchFamily="34" charset="-122"/>
-                          <a:cs typeface="IBM Plex Sans" pitchFamily="34" charset="-120"/>
+                          <a:latin typeface="Arial" pitchFamily="34" charset="0"/>
+                          <a:ea typeface="Arial" pitchFamily="34" charset="-122"/>
+                          <a:cs typeface="Arial" pitchFamily="34" charset="-120"/>
                         </a:rPr>
                         <a:t>Never say what you are missing for them</a:t>
                       </a:r>
                       <a:endParaRPr lang="en-US" sz="1300" dirty="0">
-                        <a:latin typeface="IBM Plex Sans" charset="0"/>
-                        <a:ea typeface="IBM Plex Sans" charset="0"/>
-                        <a:cs typeface="IBM Plex Sans" charset="0"/>
+                        <a:latin typeface="Arial" charset="0"/>
+                        <a:ea typeface="Arial" charset="0"/>
+                        <a:cs typeface="Arial" charset="0"/>
                       </a:endParaRPr>
                     </a:p>
                   </a:txBody>
@@ -5884,9 +5884,9 @@
                 <a:solidFill>
                   <a:srgbClr val="1B2240"/>
                 </a:solidFill>
-                <a:latin typeface="Schibsted Grotesk" pitchFamily="34" charset="0"/>
-                <a:ea typeface="Schibsted Grotesk" pitchFamily="34" charset="-122"/>
-                <a:cs typeface="Schibsted Grotesk" pitchFamily="34" charset="-120"/>
+                <a:latin typeface="Arial" pitchFamily="34" charset="0"/>
+                <a:ea typeface="Arial" pitchFamily="34" charset="-122"/>
+                <a:cs typeface="Arial" pitchFamily="34" charset="-120"/>
               </a:rPr>
               <a:t>SkillProof</a:t>
             </a:r>
@@ -5923,9 +5923,9 @@
                 <a:solidFill>
                   <a:srgbClr val="1B2240"/>
                 </a:solidFill>
-                <a:latin typeface="Schibsted Grotesk" pitchFamily="34" charset="0"/>
-                <a:ea typeface="Schibsted Grotesk" pitchFamily="34" charset="-122"/>
-                <a:cs typeface="Schibsted Grotesk" pitchFamily="34" charset="-120"/>
+                <a:latin typeface="Arial" pitchFamily="34" charset="0"/>
+                <a:ea typeface="Arial" pitchFamily="34" charset="-122"/>
+                <a:cs typeface="Arial" pitchFamily="34" charset="-120"/>
               </a:rPr>
               <a:t>SkillProof</a:t>
             </a:r>
@@ -5962,9 +5962,9 @@
                 <a:solidFill>
                   <a:srgbClr val="5E6785"/>
                 </a:solidFill>
-                <a:latin typeface="IBM Plex Sans" pitchFamily="34" charset="0"/>
-                <a:ea typeface="IBM Plex Sans" pitchFamily="34" charset="-122"/>
-                <a:cs typeface="IBM Plex Sans" pitchFamily="34" charset="-120"/>
+                <a:latin typeface="Arial" pitchFamily="34" charset="0"/>
+                <a:ea typeface="Arial" pitchFamily="34" charset="-122"/>
+                <a:cs typeface="Arial" pitchFamily="34" charset="-120"/>
               </a:rPr>
               <a:t>Skills proven, not claimed. Four steps, all visible to the student.</a:t>
             </a:r>
@@ -6021,9 +6021,9 @@
                 <a:solidFill>
                   <a:srgbClr val="1B2240"/>
                 </a:solidFill>
-                <a:latin typeface="Schibsted Grotesk" pitchFamily="34" charset="0"/>
-                <a:ea typeface="Schibsted Grotesk" pitchFamily="34" charset="-122"/>
-                <a:cs typeface="Schibsted Grotesk" pitchFamily="34" charset="-120"/>
+                <a:latin typeface="Arial" pitchFamily="34" charset="0"/>
+                <a:ea typeface="Arial" pitchFamily="34" charset="-122"/>
+                <a:cs typeface="Arial" pitchFamily="34" charset="-120"/>
               </a:rPr>
               <a:t>Collect evidence</a:t>
             </a:r>
@@ -6060,9 +6060,9 @@
                 <a:solidFill>
                   <a:srgbClr val="5E6785"/>
                 </a:solidFill>
-                <a:latin typeface="IBM Plex Sans" pitchFamily="34" charset="0"/>
-                <a:ea typeface="IBM Plex Sans" pitchFamily="34" charset="-122"/>
-                <a:cs typeface="IBM Plex Sans" pitchFamily="34" charset="-120"/>
+                <a:latin typeface="Arial" pitchFamily="34" charset="0"/>
+                <a:ea typeface="Arial" pitchFamily="34" charset="-122"/>
+                <a:cs typeface="Arial" pitchFamily="34" charset="-120"/>
               </a:rPr>
               <a:t>resume gives claimed skills, GitHub code gives observed skills traced to the file, a quiz gives verified skills</a:t>
             </a:r>
@@ -6119,9 +6119,9 @@
                 <a:solidFill>
                   <a:srgbClr val="1B2240"/>
                 </a:solidFill>
-                <a:latin typeface="Schibsted Grotesk" pitchFamily="34" charset="0"/>
-                <a:ea typeface="Schibsted Grotesk" pitchFamily="34" charset="-122"/>
-                <a:cs typeface="Schibsted Grotesk" pitchFamily="34" charset="-120"/>
+                <a:latin typeface="Arial" pitchFamily="34" charset="0"/>
+                <a:ea typeface="Arial" pitchFamily="34" charset="-122"/>
+                <a:cs typeface="Arial" pitchFamily="34" charset="-120"/>
               </a:rPr>
               <a:t>Price the gaps</a:t>
             </a:r>
@@ -6158,9 +6158,9 @@
                 <a:solidFill>
                   <a:srgbClr val="5E6785"/>
                 </a:solidFill>
-                <a:latin typeface="IBM Plex Sans" pitchFamily="34" charset="0"/>
-                <a:ea typeface="IBM Plex Sans" pitchFamily="34" charset="-122"/>
-                <a:cs typeface="IBM Plex Sans" pitchFamily="34" charset="-120"/>
+                <a:latin typeface="Arial" pitchFamily="34" charset="0"/>
+                <a:ea typeface="Arial" pitchFamily="34" charset="-122"/>
+                <a:cs typeface="Arial" pitchFamily="34" charset="-120"/>
               </a:rPr>
               <a:t>readiness is the job description weighted share of the role you can prove</a:t>
             </a:r>
@@ -6217,9 +6217,9 @@
                 <a:solidFill>
                   <a:srgbClr val="1B2240"/>
                 </a:solidFill>
-                <a:latin typeface="Schibsted Grotesk" pitchFamily="34" charset="0"/>
-                <a:ea typeface="Schibsted Grotesk" pitchFamily="34" charset="-122"/>
-                <a:cs typeface="Schibsted Grotesk" pitchFamily="34" charset="-120"/>
+                <a:latin typeface="Arial" pitchFamily="34" charset="0"/>
+                <a:ea typeface="Arial" pitchFamily="34" charset="-122"/>
+                <a:cs typeface="Arial" pitchFamily="34" charset="-120"/>
               </a:rPr>
               <a:t>Plan against the evidence</a:t>
             </a:r>
@@ -6256,9 +6256,9 @@
                 <a:solidFill>
                   <a:srgbClr val="5E6785"/>
                 </a:solidFill>
-                <a:latin typeface="IBM Plex Sans" pitchFamily="34" charset="0"/>
-                <a:ea typeface="IBM Plex Sans" pitchFamily="34" charset="-122"/>
-                <a:cs typeface="IBM Plex Sans" pitchFamily="34" charset="-120"/>
+                <a:latin typeface="Arial" pitchFamily="34" charset="0"/>
+                <a:ea typeface="Arial" pitchFamily="34" charset="-122"/>
+                <a:cs typeface="Arial" pitchFamily="34" charset="-120"/>
               </a:rPr>
               <a:t>ranked by cost, ordered by prerequisite, packed into your hours, ending in a proof project</a:t>
             </a:r>
@@ -6315,9 +6315,9 @@
                 <a:solidFill>
                   <a:srgbClr val="1B2240"/>
                 </a:solidFill>
-                <a:latin typeface="Schibsted Grotesk" pitchFamily="34" charset="0"/>
-                <a:ea typeface="Schibsted Grotesk" pitchFamily="34" charset="-122"/>
-                <a:cs typeface="Schibsted Grotesk" pitchFamily="34" charset="-120"/>
+                <a:latin typeface="Arial" pitchFamily="34" charset="0"/>
+                <a:ea typeface="Arial" pitchFamily="34" charset="-122"/>
+                <a:cs typeface="Arial" pitchFamily="34" charset="-120"/>
               </a:rPr>
               <a:t>Replan on proof</a:t>
             </a:r>
@@ -6354,9 +6354,9 @@
                 <a:solidFill>
                   <a:srgbClr val="5E6785"/>
                 </a:solidFill>
-                <a:latin typeface="IBM Plex Sans" pitchFamily="34" charset="0"/>
-                <a:ea typeface="IBM Plex Sans" pitchFamily="34" charset="-122"/>
-                <a:cs typeface="IBM Plex Sans" pitchFamily="34" charset="-120"/>
+                <a:latin typeface="Arial" pitchFamily="34" charset="0"/>
+                <a:ea typeface="Arial" pitchFamily="34" charset="-122"/>
+                <a:cs typeface="Arial" pitchFamily="34" charset="-120"/>
               </a:rPr>
               <a:t>every new piece of evidence recalculates the score and rebuilds the weeks you have not touched</a:t>
             </a:r>
@@ -6449,9 +6449,9 @@
                 <a:solidFill>
                   <a:srgbClr val="1B2240"/>
                 </a:solidFill>
-                <a:latin typeface="Schibsted Grotesk" pitchFamily="34" charset="0"/>
-                <a:ea typeface="Schibsted Grotesk" pitchFamily="34" charset="-122"/>
-                <a:cs typeface="Schibsted Grotesk" pitchFamily="34" charset="-120"/>
+                <a:latin typeface="Arial" pitchFamily="34" charset="0"/>
+                <a:ea typeface="Arial" pitchFamily="34" charset="-122"/>
+                <a:cs typeface="Arial" pitchFamily="34" charset="-120"/>
               </a:rPr>
               <a:t>SkillProof</a:t>
             </a:r>
@@ -6488,9 +6488,9 @@
                 <a:solidFill>
                   <a:srgbClr val="1B2240"/>
                 </a:solidFill>
-                <a:latin typeface="Schibsted Grotesk" pitchFamily="34" charset="0"/>
-                <a:ea typeface="Schibsted Grotesk" pitchFamily="34" charset="-122"/>
-                <a:cs typeface="Schibsted Grotesk" pitchFamily="34" charset="-120"/>
+                <a:latin typeface="Arial" pitchFamily="34" charset="0"/>
+                <a:ea typeface="Arial" pitchFamily="34" charset="-122"/>
+                <a:cs typeface="Arial" pitchFamily="34" charset="-120"/>
               </a:rPr>
               <a:t>One number, and the evidence behind it</a:t>
             </a:r>
@@ -6527,9 +6527,9 @@
                 <a:solidFill>
                   <a:srgbClr val="5E6785"/>
                 </a:solidFill>
-                <a:latin typeface="IBM Plex Sans" pitchFamily="34" charset="0"/>
-                <a:ea typeface="IBM Plex Sans" pitchFamily="34" charset="-122"/>
-                <a:cs typeface="IBM Plex Sans" pitchFamily="34" charset="-120"/>
+                <a:latin typeface="Arial" pitchFamily="34" charset="0"/>
+                <a:ea typeface="Arial" pitchFamily="34" charset="-122"/>
+                <a:cs typeface="Arial" pitchFamily="34" charset="-120"/>
               </a:rPr>
               <a:t>Readiness 47 out of 100 for ML Engineer. Every segment is a skill the role asks for.</a:t>
             </a:r>
@@ -6547,13 +6547,14 @@
         </p:nvPicPr>
         <p:blipFill>
           <a:blip r:embed="rId2"/>
-          <a:srcRect l="0" r="0" t="0" b="0"/>
-          <a:stretch/>
+          <a:stretch>
+            <a:fillRect/>
+          </a:stretch>
         </p:blipFill>
         <p:spPr>
           <a:xfrm>
-            <a:off x="502920" y="2377440"/>
-            <a:ext cx="7315200" cy="4023360"/>
+            <a:off x="502920" y="2423160"/>
+            <a:ext cx="6583680" cy="4114800"/>
           </a:xfrm>
           <a:prstGeom prst="rect">
             <a:avLst/>
@@ -6568,7 +6569,7 @@
         </p:nvSpPr>
         <p:spPr>
           <a:xfrm>
-            <a:off x="8229600" y="2596896"/>
+            <a:off x="7452360" y="2688336"/>
             <a:ext cx="82296" cy="402336"/>
           </a:xfrm>
           <a:prstGeom prst="rect">
@@ -6588,8 +6589,8 @@
         </p:nvSpPr>
         <p:spPr>
           <a:xfrm>
-            <a:off x="8485632" y="2468880"/>
-            <a:ext cx="3291840" cy="329184"/>
+            <a:off x="7708392" y="2560320"/>
+            <a:ext cx="4114800" cy="329184"/>
           </a:xfrm>
           <a:prstGeom prst="rect">
             <a:avLst/>
@@ -6609,9 +6610,9 @@
                 <a:solidFill>
                   <a:srgbClr val="1B2240"/>
                 </a:solidFill>
-                <a:latin typeface="Schibsted Grotesk" pitchFamily="34" charset="0"/>
-                <a:ea typeface="Schibsted Grotesk" pitchFamily="34" charset="-122"/>
-                <a:cs typeface="Schibsted Grotesk" pitchFamily="34" charset="-120"/>
+                <a:latin typeface="Arial" pitchFamily="34" charset="0"/>
+                <a:ea typeface="Arial" pitchFamily="34" charset="-122"/>
+                <a:cs typeface="Arial" pitchFamily="34" charset="-120"/>
               </a:rPr>
               <a:t>Segment width is job description demand</a:t>
             </a:r>
@@ -6627,7 +6628,7 @@
         </p:nvSpPr>
         <p:spPr>
           <a:xfrm>
-            <a:off x="8229600" y="3557016"/>
+            <a:off x="7452360" y="3648456"/>
             <a:ext cx="82296" cy="402336"/>
           </a:xfrm>
           <a:prstGeom prst="rect">
@@ -6647,8 +6648,8 @@
         </p:nvSpPr>
         <p:spPr>
           <a:xfrm>
-            <a:off x="8485632" y="3429000"/>
-            <a:ext cx="3291840" cy="329184"/>
+            <a:off x="7708392" y="3520440"/>
+            <a:ext cx="4114800" cy="329184"/>
           </a:xfrm>
           <a:prstGeom prst="rect">
             <a:avLst/>
@@ -6668,9 +6669,9 @@
                 <a:solidFill>
                   <a:srgbClr val="1B2240"/>
                 </a:solidFill>
-                <a:latin typeface="Schibsted Grotesk" pitchFamily="34" charset="0"/>
-                <a:ea typeface="Schibsted Grotesk" pitchFamily="34" charset="-122"/>
-                <a:cs typeface="Schibsted Grotesk" pitchFamily="34" charset="-120"/>
+                <a:latin typeface="Arial" pitchFamily="34" charset="0"/>
+                <a:ea typeface="Arial" pitchFamily="34" charset="-122"/>
+                <a:cs typeface="Arial" pitchFamily="34" charset="-120"/>
               </a:rPr>
               <a:t>Colour is the evidence level</a:t>
             </a:r>
@@ -6686,7 +6687,7 @@
         </p:nvSpPr>
         <p:spPr>
           <a:xfrm>
-            <a:off x="8229600" y="4517136"/>
+            <a:off x="7452360" y="4608576"/>
             <a:ext cx="82296" cy="402336"/>
           </a:xfrm>
           <a:prstGeom prst="rect">
@@ -6706,8 +6707,8 @@
         </p:nvSpPr>
         <p:spPr>
           <a:xfrm>
-            <a:off x="8485632" y="4389120"/>
-            <a:ext cx="3291840" cy="329184"/>
+            <a:off x="7708392" y="4480560"/>
+            <a:ext cx="4114800" cy="329184"/>
           </a:xfrm>
           <a:prstGeom prst="rect">
             <a:avLst/>
@@ -6727,9 +6728,9 @@
                 <a:solidFill>
                   <a:srgbClr val="1B2240"/>
                 </a:solidFill>
-                <a:latin typeface="Schibsted Grotesk" pitchFamily="34" charset="0"/>
-                <a:ea typeface="Schibsted Grotesk" pitchFamily="34" charset="-122"/>
-                <a:cs typeface="Schibsted Grotesk" pitchFamily="34" charset="-120"/>
+                <a:latin typeface="Arial" pitchFamily="34" charset="0"/>
+                <a:ea typeface="Arial" pitchFamily="34" charset="-122"/>
+                <a:cs typeface="Arial" pitchFamily="34" charset="-120"/>
               </a:rPr>
               <a:t>Fill is how much of it is proven</a:t>
             </a:r>
@@ -6822,9 +6823,9 @@
                 <a:solidFill>
                   <a:srgbClr val="1B2240"/>
                 </a:solidFill>
-                <a:latin typeface="Schibsted Grotesk" pitchFamily="34" charset="0"/>
-                <a:ea typeface="Schibsted Grotesk" pitchFamily="34" charset="-122"/>
-                <a:cs typeface="Schibsted Grotesk" pitchFamily="34" charset="-120"/>
+                <a:latin typeface="Arial" pitchFamily="34" charset="0"/>
+                <a:ea typeface="Arial" pitchFamily="34" charset="-122"/>
+                <a:cs typeface="Arial" pitchFamily="34" charset="-120"/>
               </a:rPr>
               <a:t>SkillProof</a:t>
             </a:r>
@@ -6861,9 +6862,9 @@
                 <a:solidFill>
                   <a:srgbClr val="1B2240"/>
                 </a:solidFill>
-                <a:latin typeface="Schibsted Grotesk" pitchFamily="34" charset="0"/>
-                <a:ea typeface="Schibsted Grotesk" pitchFamily="34" charset="-122"/>
-                <a:cs typeface="Schibsted Grotesk" pitchFamily="34" charset="-120"/>
+                <a:latin typeface="Arial" pitchFamily="34" charset="0"/>
+                <a:ea typeface="Arial" pitchFamily="34" charset="-122"/>
+                <a:cs typeface="Arial" pitchFamily="34" charset="-120"/>
               </a:rPr>
               <a:t>Every claim is traceable</a:t>
             </a:r>
@@ -6900,9 +6901,9 @@
                 <a:solidFill>
                   <a:srgbClr val="5E6785"/>
                 </a:solidFill>
-                <a:latin typeface="IBM Plex Sans" pitchFamily="34" charset="0"/>
-                <a:ea typeface="IBM Plex Sans" pitchFamily="34" charset="-122"/>
-                <a:cs typeface="IBM Plex Sans" pitchFamily="34" charset="-120"/>
+                <a:latin typeface="Arial" pitchFamily="34" charset="0"/>
+                <a:ea typeface="Arial" pitchFamily="34" charset="-122"/>
+                <a:cs typeface="Arial" pitchFamily="34" charset="-120"/>
               </a:rPr>
               <a:t>SQL appears in 64% of ML Engineer listings, sits on her resume, and appears in none of her nine repositories.</a:t>
             </a:r>
@@ -6920,13 +6921,14 @@
         </p:nvPicPr>
         <p:blipFill>
           <a:blip r:embed="rId2"/>
-          <a:srcRect l="0" r="0" t="0" b="0"/>
-          <a:stretch/>
+          <a:stretch>
+            <a:fillRect/>
+          </a:stretch>
         </p:blipFill>
         <p:spPr>
           <a:xfrm>
-            <a:off x="502920" y="2377440"/>
-            <a:ext cx="7315200" cy="4023360"/>
+            <a:off x="502920" y="2423160"/>
+            <a:ext cx="6583680" cy="4114800"/>
           </a:xfrm>
           <a:prstGeom prst="rect">
             <a:avLst/>
@@ -6941,7 +6943,7 @@
         </p:nvSpPr>
         <p:spPr>
           <a:xfrm>
-            <a:off x="8229600" y="2596896"/>
+            <a:off x="7452360" y="2688336"/>
             <a:ext cx="82296" cy="402336"/>
           </a:xfrm>
           <a:prstGeom prst="rect">
@@ -6961,8 +6963,8 @@
         </p:nvSpPr>
         <p:spPr>
           <a:xfrm>
-            <a:off x="8485632" y="2468880"/>
-            <a:ext cx="3291840" cy="329184"/>
+            <a:off x="7708392" y="2560320"/>
+            <a:ext cx="4114800" cy="329184"/>
           </a:xfrm>
           <a:prstGeom prst="rect">
             <a:avLst/>
@@ -6982,9 +6984,9 @@
                 <a:solidFill>
                   <a:srgbClr val="1B2240"/>
                 </a:solidFill>
-                <a:latin typeface="Schibsted Grotesk" pitchFamily="34" charset="0"/>
-                <a:ea typeface="Schibsted Grotesk" pitchFamily="34" charset="-122"/>
-                <a:cs typeface="Schibsted Grotesk" pitchFamily="34" charset="-120"/>
+                <a:latin typeface="Arial" pitchFamily="34" charset="0"/>
+                <a:ea typeface="Arial" pitchFamily="34" charset="-122"/>
+                <a:cs typeface="Arial" pitchFamily="34" charset="-120"/>
               </a:rPr>
               <a:t>Claimed</a:t>
             </a:r>
@@ -7000,8 +7002,8 @@
         </p:nvSpPr>
         <p:spPr>
           <a:xfrm>
-            <a:off x="8485632" y="2798064"/>
-            <a:ext cx="3291840" cy="457200"/>
+            <a:off x="7708392" y="2889504"/>
+            <a:ext cx="4114800" cy="457200"/>
           </a:xfrm>
           <a:prstGeom prst="rect">
             <a:avLst/>
@@ -7021,9 +7023,9 @@
                 <a:solidFill>
                   <a:srgbClr val="5E6785"/>
                 </a:solidFill>
-                <a:latin typeface="IBM Plex Sans" pitchFamily="34" charset="0"/>
-                <a:ea typeface="IBM Plex Sans" pitchFamily="34" charset="-122"/>
-                <a:cs typeface="IBM Plex Sans" pitchFamily="34" charset="-120"/>
+                <a:latin typeface="Arial" pitchFamily="34" charset="0"/>
+                <a:ea typeface="Arial" pitchFamily="34" charset="-122"/>
+                <a:cs typeface="Arial" pitchFamily="34" charset="-120"/>
               </a:rPr>
               <a:t>on the resume only</a:t>
             </a:r>
@@ -7039,7 +7041,7 @@
         </p:nvSpPr>
         <p:spPr>
           <a:xfrm>
-            <a:off x="8229600" y="3557016"/>
+            <a:off x="7452360" y="3648456"/>
             <a:ext cx="82296" cy="402336"/>
           </a:xfrm>
           <a:prstGeom prst="rect">
@@ -7059,8 +7061,8 @@
         </p:nvSpPr>
         <p:spPr>
           <a:xfrm>
-            <a:off x="8485632" y="3429000"/>
-            <a:ext cx="3291840" cy="329184"/>
+            <a:off x="7708392" y="3520440"/>
+            <a:ext cx="4114800" cy="329184"/>
           </a:xfrm>
           <a:prstGeom prst="rect">
             <a:avLst/>
@@ -7080,9 +7082,9 @@
                 <a:solidFill>
                   <a:srgbClr val="1B2240"/>
                 </a:solidFill>
-                <a:latin typeface="Schibsted Grotesk" pitchFamily="34" charset="0"/>
-                <a:ea typeface="Schibsted Grotesk" pitchFamily="34" charset="-122"/>
-                <a:cs typeface="Schibsted Grotesk" pitchFamily="34" charset="-120"/>
+                <a:latin typeface="Arial" pitchFamily="34" charset="0"/>
+                <a:ea typeface="Arial" pitchFamily="34" charset="-122"/>
+                <a:cs typeface="Arial" pitchFamily="34" charset="-120"/>
               </a:rPr>
               <a:t>Observed</a:t>
             </a:r>
@@ -7098,8 +7100,8 @@
         </p:nvSpPr>
         <p:spPr>
           <a:xfrm>
-            <a:off x="8485632" y="3758184"/>
-            <a:ext cx="3291840" cy="457200"/>
+            <a:off x="7708392" y="3849624"/>
+            <a:ext cx="4114800" cy="457200"/>
           </a:xfrm>
           <a:prstGeom prst="rect">
             <a:avLst/>
@@ -7119,9 +7121,9 @@
                 <a:solidFill>
                   <a:srgbClr val="5E6785"/>
                 </a:solidFill>
-                <a:latin typeface="IBM Plex Sans" pitchFamily="34" charset="0"/>
-                <a:ea typeface="IBM Plex Sans" pitchFamily="34" charset="-122"/>
-                <a:cs typeface="IBM Plex Sans" pitchFamily="34" charset="-120"/>
+                <a:latin typeface="Arial" pitchFamily="34" charset="0"/>
+                <a:ea typeface="Arial" pitchFamily="34" charset="-122"/>
+                <a:cs typeface="Arial" pitchFamily="34" charset="-120"/>
               </a:rPr>
               <a:t>found in code, with the repository and file named</a:t>
             </a:r>
@@ -7137,7 +7139,7 @@
         </p:nvSpPr>
         <p:spPr>
           <a:xfrm>
-            <a:off x="8229600" y="4517136"/>
+            <a:off x="7452360" y="4608576"/>
             <a:ext cx="82296" cy="402336"/>
           </a:xfrm>
           <a:prstGeom prst="rect">
@@ -7157,8 +7159,8 @@
         </p:nvSpPr>
         <p:spPr>
           <a:xfrm>
-            <a:off x="8485632" y="4389120"/>
-            <a:ext cx="3291840" cy="329184"/>
+            <a:off x="7708392" y="4480560"/>
+            <a:ext cx="4114800" cy="329184"/>
           </a:xfrm>
           <a:prstGeom prst="rect">
             <a:avLst/>
@@ -7178,9 +7180,9 @@
                 <a:solidFill>
                   <a:srgbClr val="1B2240"/>
                 </a:solidFill>
-                <a:latin typeface="Schibsted Grotesk" pitchFamily="34" charset="0"/>
-                <a:ea typeface="Schibsted Grotesk" pitchFamily="34" charset="-122"/>
-                <a:cs typeface="Schibsted Grotesk" pitchFamily="34" charset="-120"/>
+                <a:latin typeface="Arial" pitchFamily="34" charset="0"/>
+                <a:ea typeface="Arial" pitchFamily="34" charset="-122"/>
+                <a:cs typeface="Arial" pitchFamily="34" charset="-120"/>
               </a:rPr>
               <a:t>Verified</a:t>
             </a:r>
@@ -7196,8 +7198,8 @@
         </p:nvSpPr>
         <p:spPr>
           <a:xfrm>
-            <a:off x="8485632" y="4718304"/>
-            <a:ext cx="3291840" cy="457200"/>
+            <a:off x="7708392" y="4809744"/>
+            <a:ext cx="4114800" cy="457200"/>
           </a:xfrm>
           <a:prstGeom prst="rect">
             <a:avLst/>
@@ -7217,9 +7219,9 @@
                 <a:solidFill>
                   <a:srgbClr val="5E6785"/>
                 </a:solidFill>
-                <a:latin typeface="IBM Plex Sans" pitchFamily="34" charset="0"/>
-                <a:ea typeface="IBM Plex Sans" pitchFamily="34" charset="-122"/>
-                <a:cs typeface="IBM Plex Sans" pitchFamily="34" charset="-120"/>
+                <a:latin typeface="Arial" pitchFamily="34" charset="0"/>
+                <a:ea typeface="Arial" pitchFamily="34" charset="-122"/>
+                <a:cs typeface="Arial" pitchFamily="34" charset="-120"/>
               </a:rPr>
               <a:t>passed an adaptive quiz</a:t>
             </a:r>
@@ -7312,9 +7314,9 @@
                 <a:solidFill>
                   <a:srgbClr val="1B2240"/>
                 </a:solidFill>
-                <a:latin typeface="Schibsted Grotesk" pitchFamily="34" charset="0"/>
-                <a:ea typeface="Schibsted Grotesk" pitchFamily="34" charset="-122"/>
-                <a:cs typeface="Schibsted Grotesk" pitchFamily="34" charset="-120"/>
+                <a:latin typeface="Arial" pitchFamily="34" charset="0"/>
+                <a:ea typeface="Arial" pitchFamily="34" charset="-122"/>
+                <a:cs typeface="Arial" pitchFamily="34" charset="-120"/>
               </a:rPr>
               <a:t>SkillProof</a:t>
             </a:r>
@@ -7351,9 +7353,9 @@
                 <a:solidFill>
                   <a:srgbClr val="1B2240"/>
                 </a:solidFill>
-                <a:latin typeface="Schibsted Grotesk" pitchFamily="34" charset="0"/>
-                <a:ea typeface="Schibsted Grotesk" pitchFamily="34" charset="-122"/>
-                <a:cs typeface="Schibsted Grotesk" pitchFamily="34" charset="-120"/>
+                <a:latin typeface="Arial" pitchFamily="34" charset="0"/>
+                <a:ea typeface="Arial" pitchFamily="34" charset="-122"/>
+                <a:cs typeface="Arial" pitchFamily="34" charset="-120"/>
               </a:rPr>
               <a:t>Claiming is not proving</a:t>
             </a:r>
@@ -7390,9 +7392,9 @@
                 <a:solidFill>
                   <a:srgbClr val="5E6785"/>
                 </a:solidFill>
-                <a:latin typeface="IBM Plex Sans" pitchFamily="34" charset="0"/>
-                <a:ea typeface="IBM Plex Sans" pitchFamily="34" charset="-122"/>
-                <a:cs typeface="IBM Plex Sans" pitchFamily="34" charset="-120"/>
+                <a:latin typeface="Arial" pitchFamily="34" charset="0"/>
+                <a:ea typeface="Arial" pitchFamily="34" charset="-122"/>
+                <a:cs typeface="Arial" pitchFamily="34" charset="-120"/>
               </a:rPr>
               <a:t>SQL was on the resume. Under four adaptive questions it scores 25%, and the badge stays amber.</a:t>
             </a:r>
@@ -7410,13 +7412,14 @@
         </p:nvPicPr>
         <p:blipFill>
           <a:blip r:embed="rId2"/>
-          <a:srcRect l="0" r="0" t="0" b="0"/>
-          <a:stretch/>
+          <a:stretch>
+            <a:fillRect/>
+          </a:stretch>
         </p:blipFill>
         <p:spPr>
           <a:xfrm>
-            <a:off x="502920" y="2377440"/>
-            <a:ext cx="7315200" cy="4023360"/>
+            <a:off x="502920" y="2423160"/>
+            <a:ext cx="6583680" cy="4114800"/>
           </a:xfrm>
           <a:prstGeom prst="rect">
             <a:avLst/>
@@ -7431,7 +7434,7 @@
         </p:nvSpPr>
         <p:spPr>
           <a:xfrm>
-            <a:off x="8229600" y="2596896"/>
+            <a:off x="7452360" y="2688336"/>
             <a:ext cx="82296" cy="402336"/>
           </a:xfrm>
           <a:prstGeom prst="rect">
@@ -7451,8 +7454,8 @@
         </p:nvSpPr>
         <p:spPr>
           <a:xfrm>
-            <a:off x="8485632" y="2468880"/>
-            <a:ext cx="3291840" cy="329184"/>
+            <a:off x="7708392" y="2560320"/>
+            <a:ext cx="4114800" cy="329184"/>
           </a:xfrm>
           <a:prstGeom prst="rect">
             <a:avLst/>
@@ -7472,9 +7475,9 @@
                 <a:solidFill>
                   <a:srgbClr val="1B2240"/>
                 </a:solidFill>
-                <a:latin typeface="Schibsted Grotesk" pitchFamily="34" charset="0"/>
-                <a:ea typeface="Schibsted Grotesk" pitchFamily="34" charset="-122"/>
-                <a:cs typeface="Schibsted Grotesk" pitchFamily="34" charset="-120"/>
+                <a:latin typeface="Arial" pitchFamily="34" charset="0"/>
+                <a:ea typeface="Arial" pitchFamily="34" charset="-122"/>
+                <a:cs typeface="Arial" pitchFamily="34" charset="-120"/>
               </a:rPr>
               <a:t>Harder after a correct answer, easier after a wrong one</a:t>
             </a:r>
@@ -7490,7 +7493,7 @@
         </p:nvSpPr>
         <p:spPr>
           <a:xfrm>
-            <a:off x="8229600" y="3557016"/>
+            <a:off x="7452360" y="3648456"/>
             <a:ext cx="82296" cy="402336"/>
           </a:xfrm>
           <a:prstGeom prst="rect">
@@ -7510,8 +7513,8 @@
         </p:nvSpPr>
         <p:spPr>
           <a:xfrm>
-            <a:off x="8485632" y="3429000"/>
-            <a:ext cx="3291840" cy="329184"/>
+            <a:off x="7708392" y="3520440"/>
+            <a:ext cx="4114800" cy="329184"/>
           </a:xfrm>
           <a:prstGeom prst="rect">
             <a:avLst/>
@@ -7531,9 +7534,9 @@
                 <a:solidFill>
                   <a:srgbClr val="1B2240"/>
                 </a:solidFill>
-                <a:latin typeface="Schibsted Grotesk" pitchFamily="34" charset="0"/>
-                <a:ea typeface="Schibsted Grotesk" pitchFamily="34" charset="-122"/>
-                <a:cs typeface="Schibsted Grotesk" pitchFamily="34" charset="-120"/>
+                <a:latin typeface="Arial" pitchFamily="34" charset="0"/>
+                <a:ea typeface="Arial" pitchFamily="34" charset="-122"/>
+                <a:cs typeface="Arial" pitchFamily="34" charset="-120"/>
               </a:rPr>
               <a:t>Scored by difficulty weight, not raw count</a:t>
             </a:r>
@@ -7549,7 +7552,7 @@
         </p:nvSpPr>
         <p:spPr>
           <a:xfrm>
-            <a:off x="8229600" y="4517136"/>
+            <a:off x="7452360" y="4608576"/>
             <a:ext cx="82296" cy="402336"/>
           </a:xfrm>
           <a:prstGeom prst="rect">
@@ -7569,8 +7572,8 @@
         </p:nvSpPr>
         <p:spPr>
           <a:xfrm>
-            <a:off x="8485632" y="4389120"/>
-            <a:ext cx="3291840" cy="329184"/>
+            <a:off x="7708392" y="4480560"/>
+            <a:ext cx="4114800" cy="329184"/>
           </a:xfrm>
           <a:prstGeom prst="rect">
             <a:avLst/>
@@ -7590,9 +7593,9 @@
                 <a:solidFill>
                   <a:srgbClr val="1B2240"/>
                 </a:solidFill>
-                <a:latin typeface="Schibsted Grotesk" pitchFamily="34" charset="0"/>
-                <a:ea typeface="Schibsted Grotesk" pitchFamily="34" charset="-122"/>
-                <a:cs typeface="Schibsted Grotesk" pitchFamily="34" charset="-120"/>
+                <a:latin typeface="Arial" pitchFamily="34" charset="0"/>
+                <a:ea typeface="Arial" pitchFamily="34" charset="-122"/>
+                <a:cs typeface="Arial" pitchFamily="34" charset="-120"/>
               </a:rPr>
               <a:t>The answer never reaches the browser before you answer</a:t>
             </a:r>
@@ -7685,9 +7688,9 @@
                 <a:solidFill>
                   <a:srgbClr val="1B2240"/>
                 </a:solidFill>
-                <a:latin typeface="Schibsted Grotesk" pitchFamily="34" charset="0"/>
-                <a:ea typeface="Schibsted Grotesk" pitchFamily="34" charset="-122"/>
-                <a:cs typeface="Schibsted Grotesk" pitchFamily="34" charset="-120"/>
+                <a:latin typeface="Arial" pitchFamily="34" charset="0"/>
+                <a:ea typeface="Arial" pitchFamily="34" charset="-122"/>
+                <a:cs typeface="Arial" pitchFamily="34" charset="-120"/>
               </a:rPr>
               <a:t>SkillProof</a:t>
             </a:r>
@@ -7724,9 +7727,9 @@
                 <a:solidFill>
                   <a:srgbClr val="1B2240"/>
                 </a:solidFill>
-                <a:latin typeface="Schibsted Grotesk" pitchFamily="34" charset="0"/>
-                <a:ea typeface="Schibsted Grotesk" pitchFamily="34" charset="-122"/>
-                <a:cs typeface="Schibsted Grotesk" pitchFamily="34" charset="-120"/>
+                <a:latin typeface="Arial" pitchFamily="34" charset="0"/>
+                <a:ea typeface="Arial" pitchFamily="34" charset="-122"/>
+                <a:cs typeface="Arial" pitchFamily="34" charset="-120"/>
               </a:rPr>
               <a:t>A roadmap that answers why</a:t>
             </a:r>
@@ -7763,9 +7766,9 @@
                 <a:solidFill>
                   <a:srgbClr val="5E6785"/>
                 </a:solidFill>
-                <a:latin typeface="IBM Plex Sans" pitchFamily="34" charset="0"/>
-                <a:ea typeface="IBM Plex Sans" pitchFamily="34" charset="-122"/>
-                <a:cs typeface="IBM Plex Sans" pitchFamily="34" charset="-120"/>
+                <a:latin typeface="Arial" pitchFamily="34" charset="0"/>
+                <a:ea typeface="Arial" pitchFamily="34" charset="-122"/>
+                <a:cs typeface="Arial" pitchFamily="34" charset="-120"/>
               </a:rPr>
               <a:t>Eight weeks, eight hours a week, nothing over budget, prerequisites respected.</a:t>
             </a:r>
@@ -7783,13 +7786,14 @@
         </p:nvPicPr>
         <p:blipFill>
           <a:blip r:embed="rId2"/>
-          <a:srcRect l="0" r="0" t="0" b="0"/>
-          <a:stretch/>
+          <a:stretch>
+            <a:fillRect/>
+          </a:stretch>
         </p:blipFill>
         <p:spPr>
           <a:xfrm>
-            <a:off x="502920" y="2377440"/>
-            <a:ext cx="7315200" cy="4023360"/>
+            <a:off x="502920" y="2423160"/>
+            <a:ext cx="6583680" cy="4114800"/>
           </a:xfrm>
           <a:prstGeom prst="rect">
             <a:avLst/>
@@ -7804,7 +7808,7 @@
         </p:nvSpPr>
         <p:spPr>
           <a:xfrm>
-            <a:off x="8229600" y="2596896"/>
+            <a:off x="7452360" y="2688336"/>
             <a:ext cx="82296" cy="402336"/>
           </a:xfrm>
           <a:prstGeom prst="rect">
@@ -7824,8 +7828,8 @@
         </p:nvSpPr>
         <p:spPr>
           <a:xfrm>
-            <a:off x="8485632" y="2468880"/>
-            <a:ext cx="3291840" cy="329184"/>
+            <a:off x="7708392" y="2560320"/>
+            <a:ext cx="4114800" cy="329184"/>
           </a:xfrm>
           <a:prstGeom prst="rect">
             <a:avLst/>
@@ -7845,9 +7849,9 @@
                 <a:solidFill>
                   <a:srgbClr val="1B2240"/>
                 </a:solidFill>
-                <a:latin typeface="Schibsted Grotesk" pitchFamily="34" charset="0"/>
-                <a:ea typeface="Schibsted Grotesk" pitchFamily="34" charset="-122"/>
-                <a:cs typeface="Schibsted Grotesk" pitchFamily="34" charset="-120"/>
+                <a:latin typeface="Arial" pitchFamily="34" charset="0"/>
+                <a:ea typeface="Arial" pitchFamily="34" charset="-122"/>
+                <a:cs typeface="Arial" pitchFamily="34" charset="-120"/>
               </a:rPr>
               <a:t>Why is written in numbers, not motivation</a:t>
             </a:r>
@@ -7863,7 +7867,7 @@
         </p:nvSpPr>
         <p:spPr>
           <a:xfrm>
-            <a:off x="8229600" y="3557016"/>
+            <a:off x="7452360" y="3648456"/>
             <a:ext cx="82296" cy="402336"/>
           </a:xfrm>
           <a:prstGeom prst="rect">
@@ -7883,8 +7887,8 @@
         </p:nvSpPr>
         <p:spPr>
           <a:xfrm>
-            <a:off x="8485632" y="3429000"/>
-            <a:ext cx="3291840" cy="329184"/>
+            <a:off x="7708392" y="3520440"/>
+            <a:ext cx="4114800" cy="329184"/>
           </a:xfrm>
           <a:prstGeom prst="rect">
             <a:avLst/>
@@ -7904,9 +7908,9 @@
                 <a:solidFill>
                   <a:srgbClr val="1B2240"/>
                 </a:solidFill>
-                <a:latin typeface="Schibsted Grotesk" pitchFamily="34" charset="0"/>
-                <a:ea typeface="Schibsted Grotesk" pitchFamily="34" charset="-122"/>
-                <a:cs typeface="Schibsted Grotesk" pitchFamily="34" charset="-120"/>
+                <a:latin typeface="Arial" pitchFamily="34" charset="0"/>
+                <a:ea typeface="Arial" pitchFamily="34" charset="-122"/>
+                <a:cs typeface="Arial" pitchFamily="34" charset="-120"/>
               </a:rPr>
               <a:t>Resources come from a whitelist, so no invented links</a:t>
             </a:r>
@@ -7922,7 +7926,7 @@
         </p:nvSpPr>
         <p:spPr>
           <a:xfrm>
-            <a:off x="8229600" y="4517136"/>
+            <a:off x="7452360" y="4608576"/>
             <a:ext cx="82296" cy="402336"/>
           </a:xfrm>
           <a:prstGeom prst="rect">
@@ -7942,8 +7946,8 @@
         </p:nvSpPr>
         <p:spPr>
           <a:xfrm>
-            <a:off x="8485632" y="4389120"/>
-            <a:ext cx="3291840" cy="329184"/>
+            <a:off x="7708392" y="4480560"/>
+            <a:ext cx="4114800" cy="329184"/>
           </a:xfrm>
           <a:prstGeom prst="rect">
             <a:avLst/>
@@ -7963,9 +7967,9 @@
                 <a:solidFill>
                   <a:srgbClr val="1B2240"/>
                 </a:solidFill>
-                <a:latin typeface="Schibsted Grotesk" pitchFamily="34" charset="0"/>
-                <a:ea typeface="Schibsted Grotesk" pitchFamily="34" charset="-122"/>
-                <a:cs typeface="Schibsted Grotesk" pitchFamily="34" charset="-120"/>
+                <a:latin typeface="Arial" pitchFamily="34" charset="0"/>
+                <a:ea typeface="Arial" pitchFamily="34" charset="-122"/>
+                <a:cs typeface="Arial" pitchFamily="34" charset="-120"/>
               </a:rPr>
               <a:t>Every item ends in a proof project with checkable criteria</a:t>
             </a:r>
@@ -8058,9 +8062,9 @@
                 <a:solidFill>
                   <a:srgbClr val="1B2240"/>
                 </a:solidFill>
-                <a:latin typeface="Schibsted Grotesk" pitchFamily="34" charset="0"/>
-                <a:ea typeface="Schibsted Grotesk" pitchFamily="34" charset="-122"/>
-                <a:cs typeface="Schibsted Grotesk" pitchFamily="34" charset="-120"/>
+                <a:latin typeface="Arial" pitchFamily="34" charset="0"/>
+                <a:ea typeface="Arial" pitchFamily="34" charset="-122"/>
+                <a:cs typeface="Arial" pitchFamily="34" charset="-120"/>
               </a:rPr>
               <a:t>SkillProof</a:t>
             </a:r>
@@ -8097,9 +8101,9 @@
                 <a:solidFill>
                   <a:srgbClr val="1B2240"/>
                 </a:solidFill>
-                <a:latin typeface="Schibsted Grotesk" pitchFamily="34" charset="0"/>
-                <a:ea typeface="Schibsted Grotesk" pitchFamily="34" charset="-122"/>
-                <a:cs typeface="Schibsted Grotesk" pitchFamily="34" charset="-120"/>
+                <a:latin typeface="Arial" pitchFamily="34" charset="0"/>
+                <a:ea typeface="Arial" pitchFamily="34" charset="-122"/>
+                <a:cs typeface="Arial" pitchFamily="34" charset="-120"/>
               </a:rPr>
               <a:t>It replans when you prove something</a:t>
             </a:r>
@@ -8136,9 +8140,9 @@
                 <a:solidFill>
                   <a:srgbClr val="5E6785"/>
                 </a:solidFill>
-                <a:latin typeface="IBM Plex Sans" pitchFamily="34" charset="0"/>
-                <a:ea typeface="IBM Plex Sans" pitchFamily="34" charset="-122"/>
-                <a:cs typeface="IBM Plex Sans" pitchFamily="34" charset="-120"/>
+                <a:latin typeface="Arial" pitchFamily="34" charset="0"/>
+                <a:ea typeface="Arial" pitchFamily="34" charset="-122"/>
+                <a:cs typeface="Arial" pitchFamily="34" charset="-120"/>
               </a:rPr>
               <a:t>Marking a task done changes nothing. Linking the repository moves the score by 8.5 points.</a:t>
             </a:r>
@@ -8156,13 +8160,14 @@
         </p:nvPicPr>
         <p:blipFill>
           <a:blip r:embed="rId2"/>
-          <a:srcRect l="0" r="0" t="0" b="0"/>
-          <a:stretch/>
+          <a:stretch>
+            <a:fillRect/>
+          </a:stretch>
         </p:blipFill>
         <p:spPr>
           <a:xfrm>
-            <a:off x="502920" y="2377440"/>
-            <a:ext cx="7315200" cy="4023360"/>
+            <a:off x="502920" y="2423160"/>
+            <a:ext cx="6583680" cy="4114800"/>
           </a:xfrm>
           <a:prstGeom prst="rect">
             <a:avLst/>
@@ -8177,7 +8182,7 @@
         </p:nvSpPr>
         <p:spPr>
           <a:xfrm>
-            <a:off x="8229600" y="2596896"/>
+            <a:off x="7452360" y="2688336"/>
             <a:ext cx="82296" cy="402336"/>
           </a:xfrm>
           <a:prstGeom prst="rect">
@@ -8197,8 +8202,8 @@
         </p:nvSpPr>
         <p:spPr>
           <a:xfrm>
-            <a:off x="8485632" y="2468880"/>
-            <a:ext cx="3291840" cy="329184"/>
+            <a:off x="7708392" y="2560320"/>
+            <a:ext cx="4114800" cy="329184"/>
           </a:xfrm>
           <a:prstGeom prst="rect">
             <a:avLst/>
@@ -8218,9 +8223,9 @@
                 <a:solidFill>
                   <a:srgbClr val="1B2240"/>
                 </a:solidFill>
-                <a:latin typeface="Schibsted Grotesk" pitchFamily="34" charset="0"/>
-                <a:ea typeface="Schibsted Grotesk" pitchFamily="34" charset="-122"/>
-                <a:cs typeface="Schibsted Grotesk" pitchFamily="34" charset="-120"/>
+                <a:latin typeface="Arial" pitchFamily="34" charset="0"/>
+                <a:ea typeface="Arial" pitchFamily="34" charset="-122"/>
+                <a:cs typeface="Arial" pitchFamily="34" charset="-120"/>
               </a:rPr>
               <a:t>Docker, FastAPI and AWS become observed evidence</a:t>
             </a:r>
@@ -8236,7 +8241,7 @@
         </p:nvSpPr>
         <p:spPr>
           <a:xfrm>
-            <a:off x="8229600" y="3557016"/>
+            <a:off x="7452360" y="3648456"/>
             <a:ext cx="82296" cy="402336"/>
           </a:xfrm>
           <a:prstGeom prst="rect">
@@ -8256,8 +8261,8 @@
         </p:nvSpPr>
         <p:spPr>
           <a:xfrm>
-            <a:off x="8485632" y="3429000"/>
-            <a:ext cx="3291840" cy="329184"/>
+            <a:off x="7708392" y="3520440"/>
+            <a:ext cx="4114800" cy="329184"/>
           </a:xfrm>
           <a:prstGeom prst="rect">
             <a:avLst/>
@@ -8277,9 +8282,9 @@
                 <a:solidFill>
                   <a:srgbClr val="1B2240"/>
                 </a:solidFill>
-                <a:latin typeface="Schibsted Grotesk" pitchFamily="34" charset="0"/>
-                <a:ea typeface="Schibsted Grotesk" pitchFamily="34" charset="-122"/>
-                <a:cs typeface="Schibsted Grotesk" pitchFamily="34" charset="-120"/>
+                <a:latin typeface="Arial" pitchFamily="34" charset="0"/>
+                <a:ea typeface="Arial" pitchFamily="34" charset="-122"/>
+                <a:cs typeface="Arial" pitchFamily="34" charset="-120"/>
               </a:rPr>
               <a:t>The plan rebuilds around what is left</a:t>
             </a:r>
@@ -8295,7 +8300,7 @@
         </p:nvSpPr>
         <p:spPr>
           <a:xfrm>
-            <a:off x="8229600" y="4517136"/>
+            <a:off x="7452360" y="4608576"/>
             <a:ext cx="82296" cy="402336"/>
           </a:xfrm>
           <a:prstGeom prst="rect">
@@ -8315,8 +8320,8 @@
         </p:nvSpPr>
         <p:spPr>
           <a:xfrm>
-            <a:off x="8485632" y="4389120"/>
-            <a:ext cx="3291840" cy="329184"/>
+            <a:off x="7708392" y="4480560"/>
+            <a:ext cx="4114800" cy="329184"/>
           </a:xfrm>
           <a:prstGeom prst="rect">
             <a:avLst/>
@@ -8336,9 +8341,9 @@
                 <a:solidFill>
                   <a:srgbClr val="1B2240"/>
                 </a:solidFill>
-                <a:latin typeface="Schibsted Grotesk" pitchFamily="34" charset="0"/>
-                <a:ea typeface="Schibsted Grotesk" pitchFamily="34" charset="-122"/>
-                <a:cs typeface="Schibsted Grotesk" pitchFamily="34" charset="-120"/>
+                <a:latin typeface="Arial" pitchFamily="34" charset="0"/>
+                <a:ea typeface="Arial" pitchFamily="34" charset="-122"/>
+                <a:cs typeface="Arial" pitchFamily="34" charset="-120"/>
               </a:rPr>
               <a:t>Anything the student edited stays locked</a:t>
             </a:r>

</xml_diff>

<commit_message>
chore(docs): refresh screenshots, deck and video against production with the ceiling
</commit_message>
<xml_diff>
--- a/docs/SkillProof_Pitch.pptx
+++ b/docs/SkillProof_Pitch.pptx
@@ -6738,6 +6738,104 @@
           </a:p>
         </p:txBody>
       </p:sp>
+      <p:sp>
+        <p:nvSpPr>
+          <p:cNvPr id="13" name="Shape 9"/>
+          <p:cNvSpPr/>
+          <p:nvPr/>
+        </p:nvSpPr>
+        <p:spPr>
+          <a:xfrm>
+            <a:off x="7452360" y="5568696"/>
+            <a:ext cx="82296" cy="402336"/>
+          </a:xfrm>
+          <a:prstGeom prst="rect">
+            <a:avLst/>
+          </a:prstGeom>
+          <a:solidFill>
+            <a:srgbClr val="2F4BFF"/>
+          </a:solidFill>
+          <a:ln/>
+        </p:spPr>
+      </p:sp>
+      <p:sp>
+        <p:nvSpPr>
+          <p:cNvPr id="14" name="Text 10"/>
+          <p:cNvSpPr/>
+          <p:nvPr/>
+        </p:nvSpPr>
+        <p:spPr>
+          <a:xfrm>
+            <a:off x="7708392" y="5440680"/>
+            <a:ext cx="4114800" cy="329184"/>
+          </a:xfrm>
+          <a:prstGeom prst="rect">
+            <a:avLst/>
+          </a:prstGeom>
+          <a:noFill/>
+          <a:ln/>
+        </p:spPr>
+        <p:txBody>
+          <a:bodyPr wrap="square" rtlCol="0" anchor="ctr"/>
+          <a:lstStyle/>
+          <a:p>
+            <a:pPr indent="0" marL="0">
+              <a:buNone/>
+            </a:pPr>
+            <a:r>
+              <a:rPr lang="en-US" sz="1700" b="1" dirty="0">
+                <a:solidFill>
+                  <a:srgbClr val="1B2240"/>
+                </a:solidFill>
+                <a:latin typeface="Arial" pitchFamily="34" charset="0"/>
+                <a:ea typeface="Arial" pitchFamily="34" charset="-122"/>
+                <a:cs typeface="Arial" pitchFamily="34" charset="-120"/>
+              </a:rPr>
+              <a:t>Ceiling: 89</a:t>
+            </a:r>
+            <a:endParaRPr lang="en-US" sz="1700" dirty="0"/>
+          </a:p>
+        </p:txBody>
+      </p:sp>
+      <p:sp>
+        <p:nvSpPr>
+          <p:cNvPr id="15" name="Text 11"/>
+          <p:cNvSpPr/>
+          <p:nvPr/>
+        </p:nvSpPr>
+        <p:spPr>
+          <a:xfrm>
+            <a:off x="7708392" y="5769864"/>
+            <a:ext cx="4114800" cy="457200"/>
+          </a:xfrm>
+          <a:prstGeom prst="rect">
+            <a:avLst/>
+          </a:prstGeom>
+          <a:noFill/>
+          <a:ln/>
+        </p:spPr>
+        <p:txBody>
+          <a:bodyPr wrap="square" rtlCol="0" anchor="ctr"/>
+          <a:lstStyle/>
+          <a:p>
+            <a:pPr indent="0" marL="0">
+              <a:buNone/>
+            </a:pPr>
+            <a:r>
+              <a:rPr lang="en-US" sz="1300" dirty="0">
+                <a:solidFill>
+                  <a:srgbClr val="5E6785"/>
+                </a:solidFill>
+                <a:latin typeface="Arial" pitchFamily="34" charset="0"/>
+                <a:ea typeface="Arial" pitchFamily="34" charset="-122"/>
+                <a:cs typeface="Arial" pitchFamily="34" charset="-120"/>
+              </a:rPr>
+              <a:t>what proving her current evidence would reach, so a gap reads as not shown yet or not learned yet</a:t>
+            </a:r>
+            <a:endParaRPr lang="en-US" sz="1300" dirty="0"/>
+          </a:p>
+        </p:txBody>
+      </p:sp>
     </p:spTree>
   </p:cSld>
   <p:clrMapOvr>

</xml_diff>

<commit_message>
fix(deck): keep the seal outside the folder the demo recorder clears
</commit_message>
<xml_diff>
--- a/docs/SkillProof_Pitch.pptx
+++ b/docs/SkillProof_Pitch.pptx
@@ -1856,7 +1856,7 @@
       </p:grpSpPr>
       <p:pic>
         <p:nvPicPr>
-          <p:cNvPr id="2" name="Image 0" descr="/Users/shubham/Desktop/skillproof/docs/screenshots/deck/seal.png">    </p:cNvPr>
+          <p:cNvPr id="2" name="Image 0" descr="/Users/shubham/Desktop/skillproof/docs/screenshots/seal.png">    </p:cNvPr>
           <p:cNvPicPr>
             <a:picLocks noChangeAspect="1"/>
           </p:cNvPicPr>
@@ -2029,7 +2029,7 @@
       </p:grpSpPr>
       <p:pic>
         <p:nvPicPr>
-          <p:cNvPr id="2" name="Image 0" descr="/Users/shubham/Desktop/skillproof/docs/screenshots/deck/seal.png">    </p:cNvPr>
+          <p:cNvPr id="2" name="Image 0" descr="/Users/shubham/Desktop/skillproof/docs/screenshots/seal.png">    </p:cNvPr>
           <p:cNvPicPr>
             <a:picLocks noChangeAspect="1"/>
           </p:cNvPicPr>
@@ -2594,7 +2594,7 @@
       </p:grpSpPr>
       <p:pic>
         <p:nvPicPr>
-          <p:cNvPr id="2" name="Image 0" descr="/Users/shubham/Desktop/skillproof/docs/screenshots/deck/seal.png">    </p:cNvPr>
+          <p:cNvPr id="2" name="Image 0" descr="/Users/shubham/Desktop/skillproof/docs/screenshots/seal.png">    </p:cNvPr>
           <p:cNvPicPr>
             <a:picLocks noChangeAspect="1"/>
           </p:cNvPicPr>
@@ -3556,7 +3556,7 @@
       </p:grpSpPr>
       <p:pic>
         <p:nvPicPr>
-          <p:cNvPr id="2" name="Image 0" descr="/Users/shubham/Desktop/skillproof/docs/screenshots/deck/seal.png">    </p:cNvPr>
+          <p:cNvPr id="2" name="Image 0" descr="/Users/shubham/Desktop/skillproof/docs/screenshots/seal.png">    </p:cNvPr>
           <p:cNvPicPr>
             <a:picLocks noChangeAspect="1"/>
           </p:cNvPicPr>
@@ -4109,7 +4109,7 @@
       </p:grpSpPr>
       <p:pic>
         <p:nvPicPr>
-          <p:cNvPr id="2" name="Image 0" descr="/Users/shubham/Desktop/skillproof/docs/screenshots/deck/seal.png">    </p:cNvPr>
+          <p:cNvPr id="2" name="Image 0" descr="/Users/shubham/Desktop/skillproof/docs/screenshots/seal.png">    </p:cNvPr>
           <p:cNvPicPr>
             <a:picLocks noChangeAspect="1"/>
           </p:cNvPicPr>
@@ -4674,7 +4674,7 @@
       </p:grpSpPr>
       <p:pic>
         <p:nvPicPr>
-          <p:cNvPr id="2" name="Image 0" descr="/Users/shubham/Desktop/skillproof/docs/screenshots/deck/seal.png">    </p:cNvPr>
+          <p:cNvPr id="2" name="Image 0" descr="/Users/shubham/Desktop/skillproof/docs/screenshots/seal.png">    </p:cNvPr>
           <p:cNvPicPr>
             <a:picLocks noChangeAspect="1"/>
           </p:cNvPicPr>
@@ -5833,7 +5833,7 @@
       </p:grpSpPr>
       <p:pic>
         <p:nvPicPr>
-          <p:cNvPr id="2" name="Image 0" descr="/Users/shubham/Desktop/skillproof/docs/screenshots/deck/seal.png">    </p:cNvPr>
+          <p:cNvPr id="2" name="Image 0" descr="/Users/shubham/Desktop/skillproof/docs/screenshots/seal.png">    </p:cNvPr>
           <p:cNvPicPr>
             <a:picLocks noChangeAspect="1"/>
           </p:cNvPicPr>
@@ -6398,7 +6398,7 @@
       </p:grpSpPr>
       <p:pic>
         <p:nvPicPr>
-          <p:cNvPr id="2" name="Image 0" descr="/Users/shubham/Desktop/skillproof/docs/screenshots/deck/seal.png">    </p:cNvPr>
+          <p:cNvPr id="2" name="Image 0" descr="/Users/shubham/Desktop/skillproof/docs/screenshots/seal.png">    </p:cNvPr>
           <p:cNvPicPr>
             <a:picLocks noChangeAspect="1"/>
           </p:cNvPicPr>
@@ -6870,7 +6870,7 @@
       </p:grpSpPr>
       <p:pic>
         <p:nvPicPr>
-          <p:cNvPr id="2" name="Image 0" descr="/Users/shubham/Desktop/skillproof/docs/screenshots/deck/seal.png">    </p:cNvPr>
+          <p:cNvPr id="2" name="Image 0" descr="/Users/shubham/Desktop/skillproof/docs/screenshots/seal.png">    </p:cNvPr>
           <p:cNvPicPr>
             <a:picLocks noChangeAspect="1"/>
           </p:cNvPicPr>
@@ -7361,7 +7361,7 @@
       </p:grpSpPr>
       <p:pic>
         <p:nvPicPr>
-          <p:cNvPr id="2" name="Image 0" descr="/Users/shubham/Desktop/skillproof/docs/screenshots/deck/seal.png">    </p:cNvPr>
+          <p:cNvPr id="2" name="Image 0" descr="/Users/shubham/Desktop/skillproof/docs/screenshots/seal.png">    </p:cNvPr>
           <p:cNvPicPr>
             <a:picLocks noChangeAspect="1"/>
           </p:cNvPicPr>
@@ -7735,7 +7735,7 @@
       </p:grpSpPr>
       <p:pic>
         <p:nvPicPr>
-          <p:cNvPr id="2" name="Image 0" descr="/Users/shubham/Desktop/skillproof/docs/screenshots/deck/seal.png">    </p:cNvPr>
+          <p:cNvPr id="2" name="Image 0" descr="/Users/shubham/Desktop/skillproof/docs/screenshots/seal.png">    </p:cNvPr>
           <p:cNvPicPr>
             <a:picLocks noChangeAspect="1"/>
           </p:cNvPicPr>
@@ -8109,7 +8109,7 @@
       </p:grpSpPr>
       <p:pic>
         <p:nvPicPr>
-          <p:cNvPr id="2" name="Image 0" descr="/Users/shubham/Desktop/skillproof/docs/screenshots/deck/seal.png">    </p:cNvPr>
+          <p:cNvPr id="2" name="Image 0" descr="/Users/shubham/Desktop/skillproof/docs/screenshots/seal.png">    </p:cNvPr>
           <p:cNvPicPr>
             <a:picLocks noChangeAspect="1"/>
           </p:cNvPicPr>

</xml_diff>

<commit_message>
docs: regenerate every artifact from production
Screenshots, deck, demo video and voice over all come from the deployed
redesign rather than the old UI.

- the recorder drove selectors and copy that no longer exist, so it now
  follows the new flow through the Skills page and the side sheet
- every narration line was counted against its own window at 150 words a
  minute; the close needed a longer hold to fit the tagline, and the video
  runs 2:57
- the deck's screenshot slides and its wording use the on screen labels,
  with the code name kept once in the note for judges
- the walkthrough gains a UI kyun aisa hai section with five decisions and
  two more judge questions
- the recorder was over the file length rule, so the quiz player moved to
  scripts/demo-quiz.ts
</commit_message>
<xml_diff>
--- a/docs/SkillProof_Pitch.pptx
+++ b/docs/SkillProof_Pitch.pptx
@@ -3944,7 +3944,7 @@
                 <a:ea typeface="Arial" pitchFamily="34" charset="-122"/>
                 <a:cs typeface="Arial" pitchFamily="34" charset="-120"/>
               </a:rPr>
-              <a:t>live job description ingestion, Hindi interface, mentor review as a fourth evidence level</a:t>
+              <a:t>live job post ingestion, Hindi interface, mentor review as a fourth kind of proof</a:t>
             </a:r>
             <a:endParaRPr lang="en-US" sz="1300" dirty="0"/>
           </a:p>
@@ -4023,7 +4023,7 @@
                 <a:ea typeface="Arial" pitchFamily="34" charset="-122"/>
                 <a:cs typeface="Arial" pitchFamily="34" charset="-120"/>
               </a:rPr>
-              <a:t>https://skillproof-dev-x9.vercel.app</a:t>
+              <a:t>https://skillproof.vercel.app</a:t>
             </a:r>
             <a:pPr indent="0" marL="0">
               <a:lnSpc>
@@ -6064,7 +6064,7 @@
                 <a:ea typeface="Arial" pitchFamily="34" charset="-122"/>
                 <a:cs typeface="Arial" pitchFamily="34" charset="-120"/>
               </a:rPr>
-              <a:t>resume gives claimed skills, GitHub code gives observed skills traced to the file, a quiz gives verified skills</a:t>
+              <a:t>the resume gives "on your resume", GitHub gives "seen in your code" traced to the file, a test gives "tested"</a:t>
             </a:r>
             <a:endParaRPr lang="en-US" sz="1300" dirty="0"/>
           </a:p>
@@ -6162,7 +6162,7 @@
                 <a:ea typeface="Arial" pitchFamily="34" charset="-122"/>
                 <a:cs typeface="Arial" pitchFamily="34" charset="-120"/>
               </a:rPr>
-              <a:t>readiness is the job description weighted share of the role you can prove</a:t>
+              <a:t>job readiness is the demand weighted share of the role the student can actually prove</a:t>
             </a:r>
             <a:endParaRPr lang="en-US" sz="1300" dirty="0"/>
           </a:p>
@@ -6492,7 +6492,7 @@
                 <a:ea typeface="Arial" pitchFamily="34" charset="-122"/>
                 <a:cs typeface="Arial" pitchFamily="34" charset="-120"/>
               </a:rPr>
-              <a:t>One number, and the evidence behind it</a:t>
+              <a:t>One number, and a sentence saying what it means</a:t>
             </a:r>
             <a:endParaRPr lang="en-US" sz="3400" dirty="0"/>
           </a:p>
@@ -6531,7 +6531,7 @@
                 <a:ea typeface="Arial" pitchFamily="34" charset="-122"/>
                 <a:cs typeface="Arial" pitchFamily="34" charset="-120"/>
               </a:rPr>
-              <a:t>Readiness 47 out of 100 for ML Engineer. Every segment is a skill the role asks for.</a:t>
+              <a:t>"You are 47% ready for ML Engineer roles." Every block in the bar is a skill the role asks for.</a:t>
             </a:r>
             <a:endParaRPr lang="en-US" sz="1600" dirty="0"/>
           </a:p>
@@ -6539,7 +6539,7 @@
       </p:sp>
       <p:pic>
         <p:nvPicPr>
-          <p:cNvPr id="6" name="Image 1" descr="/Users/shubham/Desktop/skillproof/docs/screenshots/deck/03-dashboard.png">    </p:cNvPr>
+          <p:cNvPr id="6" name="Image 1" descr="/Users/shubham/Desktop/skillproof/docs/screenshots/deck/03-overview.png">    </p:cNvPr>
           <p:cNvPicPr>
             <a:picLocks noChangeAspect="1"/>
           </p:cNvPicPr>
@@ -6614,7 +6614,7 @@
                 <a:ea typeface="Arial" pitchFamily="34" charset="-122"/>
                 <a:cs typeface="Arial" pitchFamily="34" charset="-120"/>
               </a:rPr>
-              <a:t>Segment width is job description demand</a:t>
+              <a:t>Block width is how often real job posts ask for it</a:t>
             </a:r>
             <a:endParaRPr lang="en-US" sz="1700" dirty="0"/>
           </a:p>
@@ -6673,7 +6673,7 @@
                 <a:ea typeface="Arial" pitchFamily="34" charset="-122"/>
                 <a:cs typeface="Arial" pitchFamily="34" charset="-120"/>
               </a:rPr>
-              <a:t>Colour is the evidence level</a:t>
+              <a:t>Colour is how far the student has proved it</a:t>
             </a:r>
             <a:endParaRPr lang="en-US" sz="1700" dirty="0"/>
           </a:p>
@@ -6732,7 +6732,7 @@
                 <a:ea typeface="Arial" pitchFamily="34" charset="-122"/>
                 <a:cs typeface="Arial" pitchFamily="34" charset="-120"/>
               </a:rPr>
-              <a:t>Fill is how much of it is proven</a:t>
+              <a:t>"You could reach 89 by proving skills you already have"</a:t>
             </a:r>
             <a:endParaRPr lang="en-US" sz="1700" dirty="0"/>
           </a:p>
@@ -6740,7 +6740,46 @@
       </p:sp>
       <p:sp>
         <p:nvSpPr>
-          <p:cNvPr id="13" name="Shape 9"/>
+          <p:cNvPr id="13" name="Text 9"/>
+          <p:cNvSpPr/>
+          <p:nvPr/>
+        </p:nvSpPr>
+        <p:spPr>
+          <a:xfrm>
+            <a:off x="7708392" y="4809744"/>
+            <a:ext cx="4114800" cy="457200"/>
+          </a:xfrm>
+          <a:prstGeom prst="rect">
+            <a:avLst/>
+          </a:prstGeom>
+          <a:noFill/>
+          <a:ln/>
+        </p:spPr>
+        <p:txBody>
+          <a:bodyPr wrap="square" rtlCol="0" anchor="ctr"/>
+          <a:lstStyle/>
+          <a:p>
+            <a:pPr indent="0" marL="0">
+              <a:buNone/>
+            </a:pPr>
+            <a:r>
+              <a:rPr lang="en-US" sz="1300" dirty="0">
+                <a:solidFill>
+                  <a:srgbClr val="5E6785"/>
+                </a:solidFill>
+                <a:latin typeface="Arial" pitchFamily="34" charset="0"/>
+                <a:ea typeface="Arial" pitchFamily="34" charset="-122"/>
+                <a:cs typeface="Arial" pitchFamily="34" charset="-120"/>
+              </a:rPr>
+              <a:t>so a gap reads as not shown yet rather than not learned yet</a:t>
+            </a:r>
+            <a:endParaRPr lang="en-US" sz="1300" dirty="0"/>
+          </a:p>
+        </p:txBody>
+      </p:sp>
+      <p:sp>
+        <p:nvSpPr>
+          <p:cNvPr id="14" name="Shape 10"/>
           <p:cNvSpPr/>
           <p:nvPr/>
         </p:nvSpPr>
@@ -6760,7 +6799,7 @@
       </p:sp>
       <p:sp>
         <p:nvSpPr>
-          <p:cNvPr id="14" name="Text 10"/>
+          <p:cNvPr id="15" name="Text 11"/>
           <p:cNvSpPr/>
           <p:nvPr/>
         </p:nvSpPr>
@@ -6791,48 +6830,9 @@
                 <a:ea typeface="Arial" pitchFamily="34" charset="-122"/>
                 <a:cs typeface="Arial" pitchFamily="34" charset="-120"/>
               </a:rPr>
-              <a:t>Ceiling: 89</a:t>
+              <a:t>One next step, and it is the only primary button on the page</a:t>
             </a:r>
             <a:endParaRPr lang="en-US" sz="1700" dirty="0"/>
-          </a:p>
-        </p:txBody>
-      </p:sp>
-      <p:sp>
-        <p:nvSpPr>
-          <p:cNvPr id="15" name="Text 11"/>
-          <p:cNvSpPr/>
-          <p:nvPr/>
-        </p:nvSpPr>
-        <p:spPr>
-          <a:xfrm>
-            <a:off x="7708392" y="5769864"/>
-            <a:ext cx="4114800" cy="457200"/>
-          </a:xfrm>
-          <a:prstGeom prst="rect">
-            <a:avLst/>
-          </a:prstGeom>
-          <a:noFill/>
-          <a:ln/>
-        </p:spPr>
-        <p:txBody>
-          <a:bodyPr wrap="square" rtlCol="0" anchor="ctr"/>
-          <a:lstStyle/>
-          <a:p>
-            <a:pPr indent="0" marL="0">
-              <a:buNone/>
-            </a:pPr>
-            <a:r>
-              <a:rPr lang="en-US" sz="1300" dirty="0">
-                <a:solidFill>
-                  <a:srgbClr val="5E6785"/>
-                </a:solidFill>
-                <a:latin typeface="Arial" pitchFamily="34" charset="0"/>
-                <a:ea typeface="Arial" pitchFamily="34" charset="-122"/>
-                <a:cs typeface="Arial" pitchFamily="34" charset="-120"/>
-              </a:rPr>
-              <a:t>what proving her current evidence would reach, so a gap reads as not shown yet or not learned yet</a:t>
-            </a:r>
-            <a:endParaRPr lang="en-US" sz="1300" dirty="0"/>
           </a:p>
         </p:txBody>
       </p:sp>
@@ -7003,7 +7003,7 @@
                 <a:ea typeface="Arial" pitchFamily="34" charset="-122"/>
                 <a:cs typeface="Arial" pitchFamily="34" charset="-120"/>
               </a:rPr>
-              <a:t>SQL appears in 64% of ML Engineer listings, sits on her resume, and appears in none of her nine repositories.</a:t>
+              <a:t>SQL is asked for in 64% of ML Engineer listings, sits on her resume, and appears in none of her ten repositories.</a:t>
             </a:r>
             <a:endParaRPr lang="en-US" sz="1600" dirty="0"/>
           </a:p>
@@ -7011,7 +7011,7 @@
       </p:sp>
       <p:pic>
         <p:nvPicPr>
-          <p:cNvPr id="6" name="Image 1" descr="/Users/shubham/Desktop/skillproof/docs/screenshots/deck/04-evidence-sql.png">    </p:cNvPr>
+          <p:cNvPr id="6" name="Image 1" descr="/Users/shubham/Desktop/skillproof/docs/screenshots/deck/05-evidence-sql.png">    </p:cNvPr>
           <p:cNvPicPr>
             <a:picLocks noChangeAspect="1"/>
           </p:cNvPicPr>
@@ -7086,7 +7086,7 @@
                 <a:ea typeface="Arial" pitchFamily="34" charset="-122"/>
                 <a:cs typeface="Arial" pitchFamily="34" charset="-120"/>
               </a:rPr>
-              <a:t>Claimed</a:t>
+              <a:t>On your resume</a:t>
             </a:r>
             <a:endParaRPr lang="en-US" sz="1700" dirty="0"/>
           </a:p>
@@ -7125,7 +7125,7 @@
                 <a:ea typeface="Arial" pitchFamily="34" charset="-122"/>
                 <a:cs typeface="Arial" pitchFamily="34" charset="-120"/>
               </a:rPr>
-              <a:t>on the resume only</a:t>
+              <a:t>the resume says so and nothing else does (claimed)</a:t>
             </a:r>
             <a:endParaRPr lang="en-US" sz="1300" dirty="0"/>
           </a:p>
@@ -7184,7 +7184,7 @@
                 <a:ea typeface="Arial" pitchFamily="34" charset="-122"/>
                 <a:cs typeface="Arial" pitchFamily="34" charset="-120"/>
               </a:rPr>
-              <a:t>Observed</a:t>
+              <a:t>Seen in your code</a:t>
             </a:r>
             <a:endParaRPr lang="en-US" sz="1700" dirty="0"/>
           </a:p>
@@ -7223,7 +7223,7 @@
                 <a:ea typeface="Arial" pitchFamily="34" charset="-122"/>
                 <a:cs typeface="Arial" pitchFamily="34" charset="-120"/>
               </a:rPr>
-              <a:t>found in code, with the repository and file named</a:t>
+              <a:t>found in a public repository, with the file named (observed)</a:t>
             </a:r>
             <a:endParaRPr lang="en-US" sz="1300" dirty="0"/>
           </a:p>
@@ -7282,7 +7282,7 @@
                 <a:ea typeface="Arial" pitchFamily="34" charset="-122"/>
                 <a:cs typeface="Arial" pitchFamily="34" charset="-120"/>
               </a:rPr>
-              <a:t>Verified</a:t>
+              <a:t>Tested</a:t>
             </a:r>
             <a:endParaRPr lang="en-US" sz="1700" dirty="0"/>
           </a:p>
@@ -7321,7 +7321,7 @@
                 <a:ea typeface="Arial" pitchFamily="34" charset="-122"/>
                 <a:cs typeface="Arial" pitchFamily="34" charset="-120"/>
               </a:rPr>
-              <a:t>passed an adaptive quiz</a:t>
+              <a:t>passed an adaptive test (verified)</a:t>
             </a:r>
             <a:endParaRPr lang="en-US" sz="1300" dirty="0"/>
           </a:p>
@@ -7494,7 +7494,7 @@
                 <a:ea typeface="Arial" pitchFamily="34" charset="-122"/>
                 <a:cs typeface="Arial" pitchFamily="34" charset="-120"/>
               </a:rPr>
-              <a:t>SQL was on the resume. Under four adaptive questions it scores 25%, and the badge stays amber.</a:t>
+              <a:t>SQL was on the resume. Under four adaptive questions it scores 21%, the label stays "on your resume", and the score edges down.</a:t>
             </a:r>
             <a:endParaRPr lang="en-US" sz="1600" dirty="0"/>
           </a:p>
@@ -7502,7 +7502,7 @@
       </p:sp>
       <p:pic>
         <p:nvPicPr>
-          <p:cNvPr id="6" name="Image 1" descr="/Users/shubham/Desktop/skillproof/docs/screenshots/deck/09-quiz-sql-result.png">    </p:cNvPr>
+          <p:cNvPr id="6" name="Image 1" descr="/Users/shubham/Desktop/skillproof/docs/screenshots/deck/10-quiz-sql-result.png">    </p:cNvPr>
           <p:cNvPicPr>
             <a:picLocks noChangeAspect="1"/>
           </p:cNvPicPr>
@@ -7829,7 +7829,7 @@
                 <a:ea typeface="Arial" pitchFamily="34" charset="-122"/>
                 <a:cs typeface="Arial" pitchFamily="34" charset="-120"/>
               </a:rPr>
-              <a:t>A roadmap that answers why</a:t>
+              <a:t>A plan that answers why</a:t>
             </a:r>
             <a:endParaRPr lang="en-US" sz="3400" dirty="0"/>
           </a:p>
@@ -7876,7 +7876,7 @@
       </p:sp>
       <p:pic>
         <p:nvPicPr>
-          <p:cNvPr id="6" name="Image 1" descr="/Users/shubham/Desktop/skillproof/docs/screenshots/deck/11-roadmap-item.png">    </p:cNvPr>
+          <p:cNvPr id="6" name="Image 1" descr="/Users/shubham/Desktop/skillproof/docs/screenshots/deck/12-roadmap-item.png">    </p:cNvPr>
           <p:cNvPicPr>
             <a:picLocks noChangeAspect="1"/>
           </p:cNvPicPr>
@@ -8250,7 +8250,7 @@
       </p:sp>
       <p:pic>
         <p:nvPicPr>
-          <p:cNvPr id="6" name="Image 1" descr="/Users/shubham/Desktop/skillproof/docs/screenshots/deck/13-progress-replan.png">    </p:cNvPr>
+          <p:cNvPr id="6" name="Image 1" descr="/Users/shubham/Desktop/skillproof/docs/screenshots/deck/14-progress-replan.png">    </p:cNvPr>
           <p:cNvPicPr>
             <a:picLocks noChangeAspect="1"/>
           </p:cNvPicPr>
@@ -8325,7 +8325,7 @@
                 <a:ea typeface="Arial" pitchFamily="34" charset="-122"/>
                 <a:cs typeface="Arial" pitchFamily="34" charset="-120"/>
               </a:rPr>
-              <a:t>Docker, FastAPI and AWS become observed evidence</a:t>
+              <a:t>Docker, FastAPI and AWS become seen in your code</a:t>
             </a:r>
             <a:endParaRPr lang="en-US" sz="1700" dirty="0"/>
           </a:p>

</xml_diff>